<commit_message>
Added Accessiblity, Lauch and Post Launch
</commit_message>
<xml_diff>
--- a/Devon Dive Adventures Presentation.pptx
+++ b/Devon Dive Adventures Presentation.pptx
@@ -4,11 +4,22 @@
   <p:sldMasterIdLst>
     <p:sldMasterId id="2147483660" r:id="rId1"/>
   </p:sldMasterIdLst>
+  <p:notesMasterIdLst>
+    <p:notesMasterId r:id="rId14"/>
+  </p:notesMasterIdLst>
   <p:sldIdLst>
     <p:sldId id="256" r:id="rId2"/>
     <p:sldId id="257" r:id="rId3"/>
     <p:sldId id="258" r:id="rId4"/>
     <p:sldId id="259" r:id="rId5"/>
+    <p:sldId id="260" r:id="rId6"/>
+    <p:sldId id="264" r:id="rId7"/>
+    <p:sldId id="265" r:id="rId8"/>
+    <p:sldId id="263" r:id="rId9"/>
+    <p:sldId id="262" r:id="rId10"/>
+    <p:sldId id="266" r:id="rId11"/>
+    <p:sldId id="267" r:id="rId12"/>
+    <p:sldId id="268" r:id="rId13"/>
   </p:sldIdLst>
   <p:sldSz cx="12192000" cy="6858000"/>
   <p:notesSz cx="6858000" cy="9144000"/>
@@ -123,6 +134,440 @@
 </p1510:revInfo>
 </file>
 
+<file path=ppt/notesMasters/notesMaster1.xml><?xml version="1.0" encoding="utf-8"?>
+<p:notesMaster xmlns:a="http://schemas.openxmlformats.org/drawingml/2006/main" xmlns:r="http://schemas.openxmlformats.org/officeDocument/2006/relationships" xmlns:p="http://schemas.openxmlformats.org/presentationml/2006/main">
+  <p:cSld>
+    <p:bg>
+      <p:bgRef idx="1001">
+        <a:schemeClr val="bg1"/>
+      </p:bgRef>
+    </p:bg>
+    <p:spTree>
+      <p:nvGrpSpPr>
+        <p:cNvPr id="1" name=""/>
+        <p:cNvGrpSpPr/>
+        <p:nvPr/>
+      </p:nvGrpSpPr>
+      <p:grpSpPr>
+        <a:xfrm>
+          <a:off x="0" y="0"/>
+          <a:ext cx="0" cy="0"/>
+          <a:chOff x="0" y="0"/>
+          <a:chExt cx="0" cy="0"/>
+        </a:xfrm>
+      </p:grpSpPr>
+      <p:sp>
+        <p:nvSpPr>
+          <p:cNvPr id="2" name="Header Placeholder 1"/>
+          <p:cNvSpPr>
+            <a:spLocks noGrp="1"/>
+          </p:cNvSpPr>
+          <p:nvPr>
+            <p:ph type="hdr" sz="quarter"/>
+          </p:nvPr>
+        </p:nvSpPr>
+        <p:spPr>
+          <a:xfrm>
+            <a:off x="0" y="0"/>
+            <a:ext cx="2971800" cy="458788"/>
+          </a:xfrm>
+          <a:prstGeom prst="rect">
+            <a:avLst/>
+          </a:prstGeom>
+        </p:spPr>
+        <p:txBody>
+          <a:bodyPr vert="horz" lIns="91440" tIns="45720" rIns="91440" bIns="45720" rtlCol="0"/>
+          <a:lstStyle>
+            <a:lvl1pPr algn="l">
+              <a:defRPr sz="1200"/>
+            </a:lvl1pPr>
+          </a:lstStyle>
+          <a:p>
+            <a:endParaRPr lang="en-GB"/>
+          </a:p>
+        </p:txBody>
+      </p:sp>
+      <p:sp>
+        <p:nvSpPr>
+          <p:cNvPr id="3" name="Date Placeholder 2"/>
+          <p:cNvSpPr>
+            <a:spLocks noGrp="1"/>
+          </p:cNvSpPr>
+          <p:nvPr>
+            <p:ph type="dt" idx="1"/>
+          </p:nvPr>
+        </p:nvSpPr>
+        <p:spPr>
+          <a:xfrm>
+            <a:off x="3884613" y="0"/>
+            <a:ext cx="2971800" cy="458788"/>
+          </a:xfrm>
+          <a:prstGeom prst="rect">
+            <a:avLst/>
+          </a:prstGeom>
+        </p:spPr>
+        <p:txBody>
+          <a:bodyPr vert="horz" lIns="91440" tIns="45720" rIns="91440" bIns="45720" rtlCol="0"/>
+          <a:lstStyle>
+            <a:lvl1pPr algn="r">
+              <a:defRPr sz="1200"/>
+            </a:lvl1pPr>
+          </a:lstStyle>
+          <a:p>
+            <a:fld id="{479B0384-7053-4F94-B359-AD7D22C33BE8}" type="datetimeFigureOut">
+              <a:rPr lang="en-GB" smtClean="0"/>
+              <a:t>28/04/2025</a:t>
+            </a:fld>
+            <a:endParaRPr lang="en-GB"/>
+          </a:p>
+        </p:txBody>
+      </p:sp>
+      <p:sp>
+        <p:nvSpPr>
+          <p:cNvPr id="4" name="Slide Image Placeholder 3"/>
+          <p:cNvSpPr>
+            <a:spLocks noGrp="1" noRot="1" noChangeAspect="1"/>
+          </p:cNvSpPr>
+          <p:nvPr>
+            <p:ph type="sldImg" idx="2"/>
+          </p:nvPr>
+        </p:nvSpPr>
+        <p:spPr>
+          <a:xfrm>
+            <a:off x="685800" y="1143000"/>
+            <a:ext cx="5486400" cy="3086100"/>
+          </a:xfrm>
+          <a:prstGeom prst="rect">
+            <a:avLst/>
+          </a:prstGeom>
+          <a:noFill/>
+          <a:ln w="12700">
+            <a:solidFill>
+              <a:prstClr val="black"/>
+            </a:solidFill>
+          </a:ln>
+        </p:spPr>
+        <p:txBody>
+          <a:bodyPr vert="horz" lIns="91440" tIns="45720" rIns="91440" bIns="45720" rtlCol="0" anchor="ctr"/>
+          <a:lstStyle/>
+          <a:p>
+            <a:endParaRPr lang="en-GB"/>
+          </a:p>
+        </p:txBody>
+      </p:sp>
+      <p:sp>
+        <p:nvSpPr>
+          <p:cNvPr id="5" name="Notes Placeholder 4"/>
+          <p:cNvSpPr>
+            <a:spLocks noGrp="1"/>
+          </p:cNvSpPr>
+          <p:nvPr>
+            <p:ph type="body" sz="quarter" idx="3"/>
+          </p:nvPr>
+        </p:nvSpPr>
+        <p:spPr>
+          <a:xfrm>
+            <a:off x="685800" y="4400550"/>
+            <a:ext cx="5486400" cy="3600450"/>
+          </a:xfrm>
+          <a:prstGeom prst="rect">
+            <a:avLst/>
+          </a:prstGeom>
+        </p:spPr>
+        <p:txBody>
+          <a:bodyPr vert="horz" lIns="91440" tIns="45720" rIns="91440" bIns="45720" rtlCol="0"/>
+          <a:lstStyle/>
+          <a:p>
+            <a:pPr lvl="0"/>
+            <a:r>
+              <a:rPr lang="en-US"/>
+              <a:t>Click to edit Master text styles</a:t>
+            </a:r>
+          </a:p>
+          <a:p>
+            <a:pPr lvl="1"/>
+            <a:r>
+              <a:rPr lang="en-US"/>
+              <a:t>Second level</a:t>
+            </a:r>
+          </a:p>
+          <a:p>
+            <a:pPr lvl="2"/>
+            <a:r>
+              <a:rPr lang="en-US"/>
+              <a:t>Third level</a:t>
+            </a:r>
+          </a:p>
+          <a:p>
+            <a:pPr lvl="3"/>
+            <a:r>
+              <a:rPr lang="en-US"/>
+              <a:t>Fourth level</a:t>
+            </a:r>
+          </a:p>
+          <a:p>
+            <a:pPr lvl="4"/>
+            <a:r>
+              <a:rPr lang="en-US"/>
+              <a:t>Fifth level</a:t>
+            </a:r>
+            <a:endParaRPr lang="en-GB"/>
+          </a:p>
+        </p:txBody>
+      </p:sp>
+      <p:sp>
+        <p:nvSpPr>
+          <p:cNvPr id="6" name="Footer Placeholder 5"/>
+          <p:cNvSpPr>
+            <a:spLocks noGrp="1"/>
+          </p:cNvSpPr>
+          <p:nvPr>
+            <p:ph type="ftr" sz="quarter" idx="4"/>
+          </p:nvPr>
+        </p:nvSpPr>
+        <p:spPr>
+          <a:xfrm>
+            <a:off x="0" y="8685213"/>
+            <a:ext cx="2971800" cy="458787"/>
+          </a:xfrm>
+          <a:prstGeom prst="rect">
+            <a:avLst/>
+          </a:prstGeom>
+        </p:spPr>
+        <p:txBody>
+          <a:bodyPr vert="horz" lIns="91440" tIns="45720" rIns="91440" bIns="45720" rtlCol="0" anchor="b"/>
+          <a:lstStyle>
+            <a:lvl1pPr algn="l">
+              <a:defRPr sz="1200"/>
+            </a:lvl1pPr>
+          </a:lstStyle>
+          <a:p>
+            <a:endParaRPr lang="en-GB"/>
+          </a:p>
+        </p:txBody>
+      </p:sp>
+      <p:sp>
+        <p:nvSpPr>
+          <p:cNvPr id="7" name="Slide Number Placeholder 6"/>
+          <p:cNvSpPr>
+            <a:spLocks noGrp="1"/>
+          </p:cNvSpPr>
+          <p:nvPr>
+            <p:ph type="sldNum" sz="quarter" idx="5"/>
+          </p:nvPr>
+        </p:nvSpPr>
+        <p:spPr>
+          <a:xfrm>
+            <a:off x="3884613" y="8685213"/>
+            <a:ext cx="2971800" cy="458787"/>
+          </a:xfrm>
+          <a:prstGeom prst="rect">
+            <a:avLst/>
+          </a:prstGeom>
+        </p:spPr>
+        <p:txBody>
+          <a:bodyPr vert="horz" lIns="91440" tIns="45720" rIns="91440" bIns="45720" rtlCol="0" anchor="b"/>
+          <a:lstStyle>
+            <a:lvl1pPr algn="r">
+              <a:defRPr sz="1200"/>
+            </a:lvl1pPr>
+          </a:lstStyle>
+          <a:p>
+            <a:fld id="{7D6AE9A3-3AD9-4B81-A12B-4424503654F8}" type="slidenum">
+              <a:rPr lang="en-GB" smtClean="0"/>
+              <a:t>‹#›</a:t>
+            </a:fld>
+            <a:endParaRPr lang="en-GB"/>
+          </a:p>
+        </p:txBody>
+      </p:sp>
+    </p:spTree>
+    <p:extLst>
+      <p:ext uri="{BB962C8B-B14F-4D97-AF65-F5344CB8AC3E}">
+        <p14:creationId xmlns:p14="http://schemas.microsoft.com/office/powerpoint/2010/main" val="810724404"/>
+      </p:ext>
+    </p:extLst>
+  </p:cSld>
+  <p:clrMap bg1="lt1" tx1="dk1" bg2="lt2" tx2="dk2" accent1="accent1" accent2="accent2" accent3="accent3" accent4="accent4" accent5="accent5" accent6="accent6" hlink="hlink" folHlink="folHlink"/>
+  <p:notesStyle>
+    <a:lvl1pPr marL="0" algn="l" defTabSz="914400" rtl="0" eaLnBrk="1" latinLnBrk="0" hangingPunct="1">
+      <a:defRPr sz="1200" kern="1200">
+        <a:solidFill>
+          <a:schemeClr val="tx1"/>
+        </a:solidFill>
+        <a:latin typeface="+mn-lt"/>
+        <a:ea typeface="+mn-ea"/>
+        <a:cs typeface="+mn-cs"/>
+      </a:defRPr>
+    </a:lvl1pPr>
+    <a:lvl2pPr marL="457200" algn="l" defTabSz="914400" rtl="0" eaLnBrk="1" latinLnBrk="0" hangingPunct="1">
+      <a:defRPr sz="1200" kern="1200">
+        <a:solidFill>
+          <a:schemeClr val="tx1"/>
+        </a:solidFill>
+        <a:latin typeface="+mn-lt"/>
+        <a:ea typeface="+mn-ea"/>
+        <a:cs typeface="+mn-cs"/>
+      </a:defRPr>
+    </a:lvl2pPr>
+    <a:lvl3pPr marL="914400" algn="l" defTabSz="914400" rtl="0" eaLnBrk="1" latinLnBrk="0" hangingPunct="1">
+      <a:defRPr sz="1200" kern="1200">
+        <a:solidFill>
+          <a:schemeClr val="tx1"/>
+        </a:solidFill>
+        <a:latin typeface="+mn-lt"/>
+        <a:ea typeface="+mn-ea"/>
+        <a:cs typeface="+mn-cs"/>
+      </a:defRPr>
+    </a:lvl3pPr>
+    <a:lvl4pPr marL="1371600" algn="l" defTabSz="914400" rtl="0" eaLnBrk="1" latinLnBrk="0" hangingPunct="1">
+      <a:defRPr sz="1200" kern="1200">
+        <a:solidFill>
+          <a:schemeClr val="tx1"/>
+        </a:solidFill>
+        <a:latin typeface="+mn-lt"/>
+        <a:ea typeface="+mn-ea"/>
+        <a:cs typeface="+mn-cs"/>
+      </a:defRPr>
+    </a:lvl4pPr>
+    <a:lvl5pPr marL="1828800" algn="l" defTabSz="914400" rtl="0" eaLnBrk="1" latinLnBrk="0" hangingPunct="1">
+      <a:defRPr sz="1200" kern="1200">
+        <a:solidFill>
+          <a:schemeClr val="tx1"/>
+        </a:solidFill>
+        <a:latin typeface="+mn-lt"/>
+        <a:ea typeface="+mn-ea"/>
+        <a:cs typeface="+mn-cs"/>
+      </a:defRPr>
+    </a:lvl5pPr>
+    <a:lvl6pPr marL="2286000" algn="l" defTabSz="914400" rtl="0" eaLnBrk="1" latinLnBrk="0" hangingPunct="1">
+      <a:defRPr sz="1200" kern="1200">
+        <a:solidFill>
+          <a:schemeClr val="tx1"/>
+        </a:solidFill>
+        <a:latin typeface="+mn-lt"/>
+        <a:ea typeface="+mn-ea"/>
+        <a:cs typeface="+mn-cs"/>
+      </a:defRPr>
+    </a:lvl6pPr>
+    <a:lvl7pPr marL="2743200" algn="l" defTabSz="914400" rtl="0" eaLnBrk="1" latinLnBrk="0" hangingPunct="1">
+      <a:defRPr sz="1200" kern="1200">
+        <a:solidFill>
+          <a:schemeClr val="tx1"/>
+        </a:solidFill>
+        <a:latin typeface="+mn-lt"/>
+        <a:ea typeface="+mn-ea"/>
+        <a:cs typeface="+mn-cs"/>
+      </a:defRPr>
+    </a:lvl7pPr>
+    <a:lvl8pPr marL="3200400" algn="l" defTabSz="914400" rtl="0" eaLnBrk="1" latinLnBrk="0" hangingPunct="1">
+      <a:defRPr sz="1200" kern="1200">
+        <a:solidFill>
+          <a:schemeClr val="tx1"/>
+        </a:solidFill>
+        <a:latin typeface="+mn-lt"/>
+        <a:ea typeface="+mn-ea"/>
+        <a:cs typeface="+mn-cs"/>
+      </a:defRPr>
+    </a:lvl8pPr>
+    <a:lvl9pPr marL="3657600" algn="l" defTabSz="914400" rtl="0" eaLnBrk="1" latinLnBrk="0" hangingPunct="1">
+      <a:defRPr sz="1200" kern="1200">
+        <a:solidFill>
+          <a:schemeClr val="tx1"/>
+        </a:solidFill>
+        <a:latin typeface="+mn-lt"/>
+        <a:ea typeface="+mn-ea"/>
+        <a:cs typeface="+mn-cs"/>
+      </a:defRPr>
+    </a:lvl9pPr>
+  </p:notesStyle>
+</p:notesMaster>
+</file>
+
+<file path=ppt/notesSlides/notesSlide1.xml><?xml version="1.0" encoding="utf-8"?>
+<p:notes xmlns:a="http://schemas.openxmlformats.org/drawingml/2006/main" xmlns:r="http://schemas.openxmlformats.org/officeDocument/2006/relationships" xmlns:p="http://schemas.openxmlformats.org/presentationml/2006/main">
+  <p:cSld>
+    <p:spTree>
+      <p:nvGrpSpPr>
+        <p:cNvPr id="1" name=""/>
+        <p:cNvGrpSpPr/>
+        <p:nvPr/>
+      </p:nvGrpSpPr>
+      <p:grpSpPr>
+        <a:xfrm>
+          <a:off x="0" y="0"/>
+          <a:ext cx="0" cy="0"/>
+          <a:chOff x="0" y="0"/>
+          <a:chExt cx="0" cy="0"/>
+        </a:xfrm>
+      </p:grpSpPr>
+      <p:sp>
+        <p:nvSpPr>
+          <p:cNvPr id="2" name="Slide Image Placeholder 1"/>
+          <p:cNvSpPr>
+            <a:spLocks noGrp="1" noRot="1" noChangeAspect="1"/>
+          </p:cNvSpPr>
+          <p:nvPr>
+            <p:ph type="sldImg"/>
+          </p:nvPr>
+        </p:nvSpPr>
+        <p:spPr/>
+      </p:sp>
+      <p:sp>
+        <p:nvSpPr>
+          <p:cNvPr id="3" name="Notes Placeholder 2"/>
+          <p:cNvSpPr>
+            <a:spLocks noGrp="1"/>
+          </p:cNvSpPr>
+          <p:nvPr>
+            <p:ph type="body" idx="1"/>
+          </p:nvPr>
+        </p:nvSpPr>
+        <p:spPr/>
+        <p:txBody>
+          <a:bodyPr/>
+          <a:lstStyle/>
+          <a:p>
+            <a:endParaRPr lang="en-GB"/>
+          </a:p>
+        </p:txBody>
+      </p:sp>
+      <p:sp>
+        <p:nvSpPr>
+          <p:cNvPr id="4" name="Slide Number Placeholder 3"/>
+          <p:cNvSpPr>
+            <a:spLocks noGrp="1"/>
+          </p:cNvSpPr>
+          <p:nvPr>
+            <p:ph type="sldNum" sz="quarter" idx="5"/>
+          </p:nvPr>
+        </p:nvSpPr>
+        <p:spPr/>
+        <p:txBody>
+          <a:bodyPr/>
+          <a:lstStyle/>
+          <a:p>
+            <a:fld id="{7D6AE9A3-3AD9-4B81-A12B-4424503654F8}" type="slidenum">
+              <a:rPr lang="en-GB" smtClean="0"/>
+              <a:t>12</a:t>
+            </a:fld>
+            <a:endParaRPr lang="en-GB"/>
+          </a:p>
+        </p:txBody>
+      </p:sp>
+    </p:spTree>
+    <p:extLst>
+      <p:ext uri="{BB962C8B-B14F-4D97-AF65-F5344CB8AC3E}">
+        <p14:creationId xmlns:p14="http://schemas.microsoft.com/office/powerpoint/2010/main" val="2984233182"/>
+      </p:ext>
+    </p:extLst>
+  </p:cSld>
+  <p:clrMapOvr>
+    <a:masterClrMapping/>
+  </p:clrMapOvr>
+</p:notes>
+</file>
+
 <file path=ppt/slideLayouts/slideLayout1.xml><?xml version="1.0" encoding="utf-8"?>
 <p:sldLayout xmlns:a="http://schemas.openxmlformats.org/drawingml/2006/main" xmlns:r="http://schemas.openxmlformats.org/officeDocument/2006/relationships" xmlns:p="http://schemas.openxmlformats.org/presentationml/2006/main" type="title" preserve="1">
   <p:cSld name="Title Slide">
@@ -254,7 +699,7 @@
           <a:p>
             <a:fld id="{846CE7D5-CF57-46EF-B807-FDD0502418D4}" type="datetimeFigureOut">
               <a:rPr lang="en-GB" smtClean="0"/>
-              <a:t>26/04/2025</a:t>
+              <a:t>27/04/2025</a:t>
             </a:fld>
             <a:endParaRPr lang="en-GB"/>
           </a:p>
@@ -424,7 +869,7 @@
           <a:p>
             <a:fld id="{846CE7D5-CF57-46EF-B807-FDD0502418D4}" type="datetimeFigureOut">
               <a:rPr lang="en-GB" smtClean="0"/>
-              <a:t>26/04/2025</a:t>
+              <a:t>27/04/2025</a:t>
             </a:fld>
             <a:endParaRPr lang="en-GB"/>
           </a:p>
@@ -604,7 +1049,7 @@
           <a:p>
             <a:fld id="{846CE7D5-CF57-46EF-B807-FDD0502418D4}" type="datetimeFigureOut">
               <a:rPr lang="en-GB" smtClean="0"/>
-              <a:t>26/04/2025</a:t>
+              <a:t>27/04/2025</a:t>
             </a:fld>
             <a:endParaRPr lang="en-GB"/>
           </a:p>
@@ -774,7 +1219,7 @@
           <a:p>
             <a:fld id="{846CE7D5-CF57-46EF-B807-FDD0502418D4}" type="datetimeFigureOut">
               <a:rPr lang="en-GB" smtClean="0"/>
-              <a:t>26/04/2025</a:t>
+              <a:t>27/04/2025</a:t>
             </a:fld>
             <a:endParaRPr lang="en-GB"/>
           </a:p>
@@ -1020,7 +1465,7 @@
           <a:p>
             <a:fld id="{846CE7D5-CF57-46EF-B807-FDD0502418D4}" type="datetimeFigureOut">
               <a:rPr lang="en-GB" smtClean="0"/>
-              <a:t>26/04/2025</a:t>
+              <a:t>27/04/2025</a:t>
             </a:fld>
             <a:endParaRPr lang="en-GB"/>
           </a:p>
@@ -1252,7 +1697,7 @@
           <a:p>
             <a:fld id="{846CE7D5-CF57-46EF-B807-FDD0502418D4}" type="datetimeFigureOut">
               <a:rPr lang="en-GB" smtClean="0"/>
-              <a:t>26/04/2025</a:t>
+              <a:t>27/04/2025</a:t>
             </a:fld>
             <a:endParaRPr lang="en-GB"/>
           </a:p>
@@ -1619,7 +2064,7 @@
           <a:p>
             <a:fld id="{846CE7D5-CF57-46EF-B807-FDD0502418D4}" type="datetimeFigureOut">
               <a:rPr lang="en-GB" smtClean="0"/>
-              <a:t>26/04/2025</a:t>
+              <a:t>27/04/2025</a:t>
             </a:fld>
             <a:endParaRPr lang="en-GB"/>
           </a:p>
@@ -1737,7 +2182,7 @@
           <a:p>
             <a:fld id="{846CE7D5-CF57-46EF-B807-FDD0502418D4}" type="datetimeFigureOut">
               <a:rPr lang="en-GB" smtClean="0"/>
-              <a:t>26/04/2025</a:t>
+              <a:t>27/04/2025</a:t>
             </a:fld>
             <a:endParaRPr lang="en-GB"/>
           </a:p>
@@ -1832,7 +2277,7 @@
           <a:p>
             <a:fld id="{846CE7D5-CF57-46EF-B807-FDD0502418D4}" type="datetimeFigureOut">
               <a:rPr lang="en-GB" smtClean="0"/>
-              <a:t>26/04/2025</a:t>
+              <a:t>27/04/2025</a:t>
             </a:fld>
             <a:endParaRPr lang="en-GB"/>
           </a:p>
@@ -2109,7 +2554,7 @@
           <a:p>
             <a:fld id="{846CE7D5-CF57-46EF-B807-FDD0502418D4}" type="datetimeFigureOut">
               <a:rPr lang="en-GB" smtClean="0"/>
-              <a:t>26/04/2025</a:t>
+              <a:t>27/04/2025</a:t>
             </a:fld>
             <a:endParaRPr lang="en-GB"/>
           </a:p>
@@ -2366,7 +2811,7 @@
           <a:p>
             <a:fld id="{846CE7D5-CF57-46EF-B807-FDD0502418D4}" type="datetimeFigureOut">
               <a:rPr lang="en-GB" smtClean="0"/>
-              <a:t>26/04/2025</a:t>
+              <a:t>27/04/2025</a:t>
             </a:fld>
             <a:endParaRPr lang="en-GB"/>
           </a:p>
@@ -2582,7 +3027,7 @@
           <a:p>
             <a:fld id="{846CE7D5-CF57-46EF-B807-FDD0502418D4}" type="datetimeFigureOut">
               <a:rPr lang="en-GB" smtClean="0"/>
-              <a:t>26/04/2025</a:t>
+              <a:t>27/04/2025</a:t>
             </a:fld>
             <a:endParaRPr lang="en-GB"/>
           </a:p>
@@ -3045,6 +3490,668 @@
 </p:sld>
 </file>
 
+<file path=ppt/slides/slide10.xml><?xml version="1.0" encoding="utf-8"?>
+<p:sld xmlns:a="http://schemas.openxmlformats.org/drawingml/2006/main" xmlns:r="http://schemas.openxmlformats.org/officeDocument/2006/relationships" xmlns:p="http://schemas.openxmlformats.org/presentationml/2006/main">
+  <p:cSld>
+    <p:spTree>
+      <p:nvGrpSpPr>
+        <p:cNvPr id="1" name="">
+          <a:extLst>
+            <a:ext uri="{FF2B5EF4-FFF2-40B4-BE49-F238E27FC236}">
+              <a16:creationId xmlns:a16="http://schemas.microsoft.com/office/drawing/2014/main" id="{8FB8BC6A-6FBA-970F-878D-5EA31141B26A}"/>
+            </a:ext>
+          </a:extLst>
+        </p:cNvPr>
+        <p:cNvGrpSpPr/>
+        <p:nvPr/>
+      </p:nvGrpSpPr>
+      <p:grpSpPr>
+        <a:xfrm>
+          <a:off x="0" y="0"/>
+          <a:ext cx="0" cy="0"/>
+          <a:chOff x="0" y="0"/>
+          <a:chExt cx="0" cy="0"/>
+        </a:xfrm>
+      </p:grpSpPr>
+      <p:sp>
+        <p:nvSpPr>
+          <p:cNvPr id="2" name="Title 1">
+            <a:extLst>
+              <a:ext uri="{FF2B5EF4-FFF2-40B4-BE49-F238E27FC236}">
+                <a16:creationId xmlns:a16="http://schemas.microsoft.com/office/drawing/2014/main" id="{E0F23B47-3B54-4526-25C3-E23BC4099C30}"/>
+              </a:ext>
+            </a:extLst>
+          </p:cNvPr>
+          <p:cNvSpPr>
+            <a:spLocks noGrp="1"/>
+          </p:cNvSpPr>
+          <p:nvPr>
+            <p:ph type="title"/>
+          </p:nvPr>
+        </p:nvSpPr>
+        <p:spPr/>
+        <p:txBody>
+          <a:bodyPr>
+            <a:normAutofit/>
+          </a:bodyPr>
+          <a:lstStyle/>
+          <a:p>
+            <a:pPr algn="ctr"/>
+            <a:r>
+              <a:rPr lang="en-GB" sz="2800" dirty="0">
+                <a:solidFill>
+                  <a:schemeClr val="bg1"/>
+                </a:solidFill>
+              </a:rPr>
+              <a:t>Website Launch</a:t>
+            </a:r>
+            <a:endParaRPr lang="en-US" sz="2800" dirty="0">
+              <a:solidFill>
+                <a:schemeClr val="bg1"/>
+              </a:solidFill>
+            </a:endParaRPr>
+          </a:p>
+        </p:txBody>
+      </p:sp>
+      <p:sp>
+        <p:nvSpPr>
+          <p:cNvPr id="3" name="Content Placeholder 2">
+            <a:extLst>
+              <a:ext uri="{FF2B5EF4-FFF2-40B4-BE49-F238E27FC236}">
+                <a16:creationId xmlns:a16="http://schemas.microsoft.com/office/drawing/2014/main" id="{6D014A38-05E4-F563-2F3B-47E9103FBE65}"/>
+              </a:ext>
+            </a:extLst>
+          </p:cNvPr>
+          <p:cNvSpPr>
+            <a:spLocks noGrp="1"/>
+          </p:cNvSpPr>
+          <p:nvPr>
+            <p:ph idx="1"/>
+          </p:nvPr>
+        </p:nvSpPr>
+        <p:spPr>
+          <a:xfrm>
+            <a:off x="1930879" y="1423059"/>
+            <a:ext cx="8330241" cy="943903"/>
+          </a:xfrm>
+        </p:spPr>
+        <p:txBody>
+          <a:bodyPr vert="horz" lIns="91440" tIns="45720" rIns="91440" bIns="45720" rtlCol="0" anchor="t">
+            <a:normAutofit/>
+          </a:bodyPr>
+          <a:lstStyle/>
+          <a:p>
+            <a:pPr marL="0" indent="0" algn="ctr">
+              <a:buNone/>
+            </a:pPr>
+            <a:r>
+              <a:rPr lang="en-GB" u="sng" dirty="0">
+                <a:solidFill>
+                  <a:schemeClr val="bg1"/>
+                </a:solidFill>
+              </a:rPr>
+              <a:t>Pre-Launch Process </a:t>
+            </a:r>
+            <a:endParaRPr lang="en-US" u="sng" dirty="0">
+              <a:solidFill>
+                <a:schemeClr val="bg1"/>
+              </a:solidFill>
+            </a:endParaRPr>
+          </a:p>
+        </p:txBody>
+      </p:sp>
+      <p:sp>
+        <p:nvSpPr>
+          <p:cNvPr id="4" name="TextBox 3">
+            <a:extLst>
+              <a:ext uri="{FF2B5EF4-FFF2-40B4-BE49-F238E27FC236}">
+                <a16:creationId xmlns:a16="http://schemas.microsoft.com/office/drawing/2014/main" id="{0F60FBF9-9702-66EB-14A0-9562BF7EE1DA}"/>
+              </a:ext>
+            </a:extLst>
+          </p:cNvPr>
+          <p:cNvSpPr txBox="1"/>
+          <p:nvPr/>
+        </p:nvSpPr>
+        <p:spPr>
+          <a:xfrm>
+            <a:off x="103800" y="3135557"/>
+            <a:ext cx="6021236" cy="2311210"/>
+          </a:xfrm>
+          <a:prstGeom prst="rect">
+            <a:avLst/>
+          </a:prstGeom>
+          <a:noFill/>
+        </p:spPr>
+        <p:txBody>
+          <a:bodyPr rot="0" spcFirstLastPara="0" vertOverflow="overflow" horzOverflow="overflow" vert="horz" wrap="square" lIns="91440" tIns="45720" rIns="91440" bIns="45720" numCol="1" spcCol="0" rtlCol="0" fromWordArt="0" anchor="t" anchorCtr="0" forceAA="0" compatLnSpc="1">
+            <a:prstTxWarp prst="textNoShape">
+              <a:avLst/>
+            </a:prstTxWarp>
+            <a:spAutoFit/>
+          </a:bodyPr>
+          <a:lstStyle/>
+          <a:p>
+            <a:pPr algn="ctr">
+              <a:lnSpc>
+                <a:spcPct val="90000"/>
+              </a:lnSpc>
+              <a:spcBef>
+                <a:spcPts val="1000"/>
+              </a:spcBef>
+            </a:pPr>
+            <a:r>
+              <a:rPr lang="en-GB" sz="3200" dirty="0">
+                <a:solidFill>
+                  <a:schemeClr val="bg1">
+                    <a:lumMod val="75000"/>
+                  </a:schemeClr>
+                </a:solidFill>
+              </a:rPr>
+              <a:t>A final round of testing, this includes Functionality testing, Compatibility testing, Responsiveness testing, Accessibility reviews and testing. </a:t>
+            </a:r>
+          </a:p>
+        </p:txBody>
+      </p:sp>
+      <p:sp>
+        <p:nvSpPr>
+          <p:cNvPr id="6" name="TextBox 5">
+            <a:extLst>
+              <a:ext uri="{FF2B5EF4-FFF2-40B4-BE49-F238E27FC236}">
+                <a16:creationId xmlns:a16="http://schemas.microsoft.com/office/drawing/2014/main" id="{D38DA495-C6AC-2B49-D6DF-6987EF7733AF}"/>
+              </a:ext>
+            </a:extLst>
+          </p:cNvPr>
+          <p:cNvSpPr txBox="1"/>
+          <p:nvPr/>
+        </p:nvSpPr>
+        <p:spPr>
+          <a:xfrm>
+            <a:off x="6125036" y="3215470"/>
+            <a:ext cx="5661803" cy="2677656"/>
+          </a:xfrm>
+          <a:prstGeom prst="rect">
+            <a:avLst/>
+          </a:prstGeom>
+          <a:noFill/>
+        </p:spPr>
+        <p:txBody>
+          <a:bodyPr rot="0" spcFirstLastPara="0" vertOverflow="overflow" horzOverflow="overflow" vert="horz" wrap="square" lIns="91440" tIns="45720" rIns="91440" bIns="45720" numCol="1" spcCol="0" rtlCol="0" fromWordArt="0" anchor="t" anchorCtr="0" forceAA="0" compatLnSpc="1">
+            <a:prstTxWarp prst="textNoShape">
+              <a:avLst/>
+            </a:prstTxWarp>
+            <a:spAutoFit/>
+          </a:bodyPr>
+          <a:lstStyle/>
+          <a:p>
+            <a:pPr algn="ctr"/>
+            <a:r>
+              <a:rPr lang="en-GB" sz="2800" b="1" u="sng" dirty="0">
+                <a:solidFill>
+                  <a:schemeClr val="bg1"/>
+                </a:solidFill>
+                <a:cs typeface="Segoe UI"/>
+              </a:rPr>
+              <a:t>A complete content review should be done on the website to verify there are no spelling mistakes, grammatical errors or inappropriate content on the web page.</a:t>
+            </a:r>
+          </a:p>
+        </p:txBody>
+      </p:sp>
+    </p:spTree>
+    <p:extLst>
+      <p:ext uri="{BB962C8B-B14F-4D97-AF65-F5344CB8AC3E}">
+        <p14:creationId xmlns:p14="http://schemas.microsoft.com/office/powerpoint/2010/main" val="2559751016"/>
+      </p:ext>
+    </p:extLst>
+  </p:cSld>
+  <p:clrMapOvr>
+    <a:masterClrMapping/>
+  </p:clrMapOvr>
+</p:sld>
+</file>
+
+<file path=ppt/slides/slide11.xml><?xml version="1.0" encoding="utf-8"?>
+<p:sld xmlns:a="http://schemas.openxmlformats.org/drawingml/2006/main" xmlns:r="http://schemas.openxmlformats.org/officeDocument/2006/relationships" xmlns:p="http://schemas.openxmlformats.org/presentationml/2006/main">
+  <p:cSld>
+    <p:spTree>
+      <p:nvGrpSpPr>
+        <p:cNvPr id="1" name="">
+          <a:extLst>
+            <a:ext uri="{FF2B5EF4-FFF2-40B4-BE49-F238E27FC236}">
+              <a16:creationId xmlns:a16="http://schemas.microsoft.com/office/drawing/2014/main" id="{E02DD643-798C-9BB4-CF23-F10FC68115C4}"/>
+            </a:ext>
+          </a:extLst>
+        </p:cNvPr>
+        <p:cNvGrpSpPr/>
+        <p:nvPr/>
+      </p:nvGrpSpPr>
+      <p:grpSpPr>
+        <a:xfrm>
+          <a:off x="0" y="0"/>
+          <a:ext cx="0" cy="0"/>
+          <a:chOff x="0" y="0"/>
+          <a:chExt cx="0" cy="0"/>
+        </a:xfrm>
+      </p:grpSpPr>
+      <p:sp>
+        <p:nvSpPr>
+          <p:cNvPr id="2" name="Title 1">
+            <a:extLst>
+              <a:ext uri="{FF2B5EF4-FFF2-40B4-BE49-F238E27FC236}">
+                <a16:creationId xmlns:a16="http://schemas.microsoft.com/office/drawing/2014/main" id="{67D46C0A-4D23-3D27-4CA2-9DD5F0C6DB73}"/>
+              </a:ext>
+            </a:extLst>
+          </p:cNvPr>
+          <p:cNvSpPr>
+            <a:spLocks noGrp="1"/>
+          </p:cNvSpPr>
+          <p:nvPr>
+            <p:ph type="title"/>
+          </p:nvPr>
+        </p:nvSpPr>
+        <p:spPr/>
+        <p:txBody>
+          <a:bodyPr>
+            <a:normAutofit/>
+          </a:bodyPr>
+          <a:lstStyle/>
+          <a:p>
+            <a:pPr algn="ctr"/>
+            <a:r>
+              <a:rPr lang="en-GB" sz="2800" dirty="0">
+                <a:solidFill>
+                  <a:schemeClr val="bg1"/>
+                </a:solidFill>
+              </a:rPr>
+              <a:t>Website Launch</a:t>
+            </a:r>
+            <a:endParaRPr lang="en-US" sz="2800" dirty="0">
+              <a:solidFill>
+                <a:schemeClr val="bg1"/>
+              </a:solidFill>
+            </a:endParaRPr>
+          </a:p>
+        </p:txBody>
+      </p:sp>
+      <p:sp>
+        <p:nvSpPr>
+          <p:cNvPr id="3" name="Content Placeholder 2">
+            <a:extLst>
+              <a:ext uri="{FF2B5EF4-FFF2-40B4-BE49-F238E27FC236}">
+                <a16:creationId xmlns:a16="http://schemas.microsoft.com/office/drawing/2014/main" id="{21E8955A-7EF0-54FD-A949-7EA0BE79554A}"/>
+              </a:ext>
+            </a:extLst>
+          </p:cNvPr>
+          <p:cNvSpPr>
+            <a:spLocks noGrp="1"/>
+          </p:cNvSpPr>
+          <p:nvPr>
+            <p:ph idx="1"/>
+          </p:nvPr>
+        </p:nvSpPr>
+        <p:spPr>
+          <a:xfrm>
+            <a:off x="1930879" y="1423059"/>
+            <a:ext cx="8330241" cy="943903"/>
+          </a:xfrm>
+        </p:spPr>
+        <p:txBody>
+          <a:bodyPr vert="horz" lIns="91440" tIns="45720" rIns="91440" bIns="45720" rtlCol="0" anchor="t">
+            <a:normAutofit/>
+          </a:bodyPr>
+          <a:lstStyle/>
+          <a:p>
+            <a:pPr marL="0" indent="0" algn="ctr">
+              <a:buNone/>
+            </a:pPr>
+            <a:r>
+              <a:rPr lang="en-GB" u="sng" dirty="0">
+                <a:solidFill>
+                  <a:schemeClr val="bg1"/>
+                </a:solidFill>
+              </a:rPr>
+              <a:t>Post-Launch Support</a:t>
+            </a:r>
+            <a:endParaRPr lang="en-US" u="sng" dirty="0">
+              <a:solidFill>
+                <a:schemeClr val="bg1"/>
+              </a:solidFill>
+            </a:endParaRPr>
+          </a:p>
+        </p:txBody>
+      </p:sp>
+      <p:sp>
+        <p:nvSpPr>
+          <p:cNvPr id="4" name="TextBox 3">
+            <a:extLst>
+              <a:ext uri="{FF2B5EF4-FFF2-40B4-BE49-F238E27FC236}">
+                <a16:creationId xmlns:a16="http://schemas.microsoft.com/office/drawing/2014/main" id="{DF6AACE8-7732-D34A-6AF1-E9E5465CB6C3}"/>
+              </a:ext>
+            </a:extLst>
+          </p:cNvPr>
+          <p:cNvSpPr txBox="1"/>
+          <p:nvPr/>
+        </p:nvSpPr>
+        <p:spPr>
+          <a:xfrm>
+            <a:off x="83390" y="2852070"/>
+            <a:ext cx="6021236" cy="2754408"/>
+          </a:xfrm>
+          <a:prstGeom prst="rect">
+            <a:avLst/>
+          </a:prstGeom>
+          <a:noFill/>
+        </p:spPr>
+        <p:txBody>
+          <a:bodyPr rot="0" spcFirstLastPara="0" vertOverflow="overflow" horzOverflow="overflow" vert="horz" wrap="square" lIns="91440" tIns="45720" rIns="91440" bIns="45720" numCol="1" spcCol="0" rtlCol="0" fromWordArt="0" anchor="t" anchorCtr="0" forceAA="0" compatLnSpc="1">
+            <a:prstTxWarp prst="textNoShape">
+              <a:avLst/>
+            </a:prstTxWarp>
+            <a:spAutoFit/>
+          </a:bodyPr>
+          <a:lstStyle/>
+          <a:p>
+            <a:pPr algn="ctr">
+              <a:lnSpc>
+                <a:spcPct val="90000"/>
+              </a:lnSpc>
+              <a:spcBef>
+                <a:spcPts val="1000"/>
+              </a:spcBef>
+            </a:pPr>
+            <a:r>
+              <a:rPr lang="en-GB" sz="3200" b="1" u="sng" dirty="0">
+                <a:solidFill>
+                  <a:schemeClr val="bg1"/>
+                </a:solidFill>
+              </a:rPr>
+              <a:t>Technical troubleshooting involving assisting the client if any bugs, unexpected behaviour or website performance related issues are to occur.</a:t>
+            </a:r>
+            <a:endParaRPr lang="en-US" sz="3200" b="1" u="sng" dirty="0">
+              <a:solidFill>
+                <a:schemeClr val="bg1"/>
+              </a:solidFill>
+            </a:endParaRPr>
+          </a:p>
+        </p:txBody>
+      </p:sp>
+      <p:sp>
+        <p:nvSpPr>
+          <p:cNvPr id="6" name="TextBox 5">
+            <a:extLst>
+              <a:ext uri="{FF2B5EF4-FFF2-40B4-BE49-F238E27FC236}">
+                <a16:creationId xmlns:a16="http://schemas.microsoft.com/office/drawing/2014/main" id="{3F34FD2E-13BE-A98B-8767-224F81A54DF6}"/>
+              </a:ext>
+            </a:extLst>
+          </p:cNvPr>
+          <p:cNvSpPr txBox="1"/>
+          <p:nvPr/>
+        </p:nvSpPr>
+        <p:spPr>
+          <a:xfrm>
+            <a:off x="6104626" y="2999116"/>
+            <a:ext cx="5661803" cy="1815882"/>
+          </a:xfrm>
+          <a:prstGeom prst="rect">
+            <a:avLst/>
+          </a:prstGeom>
+          <a:noFill/>
+        </p:spPr>
+        <p:txBody>
+          <a:bodyPr rot="0" spcFirstLastPara="0" vertOverflow="overflow" horzOverflow="overflow" vert="horz" wrap="square" lIns="91440" tIns="45720" rIns="91440" bIns="45720" numCol="1" spcCol="0" rtlCol="0" fromWordArt="0" anchor="t" anchorCtr="0" forceAA="0" compatLnSpc="1">
+            <a:prstTxWarp prst="textNoShape">
+              <a:avLst/>
+            </a:prstTxWarp>
+            <a:spAutoFit/>
+          </a:bodyPr>
+          <a:lstStyle/>
+          <a:p>
+            <a:pPr algn="ctr"/>
+            <a:r>
+              <a:rPr lang="en-GB" sz="2800" dirty="0">
+                <a:solidFill>
+                  <a:schemeClr val="bg1">
+                    <a:lumMod val="76000"/>
+                  </a:schemeClr>
+                </a:solidFill>
+                <a:cs typeface="Segoe UI"/>
+              </a:rPr>
+              <a:t>Content Updates, to the Devon Dive site. This would allow the site to stay dynamic and relevant for returning and future users.</a:t>
+            </a:r>
+          </a:p>
+        </p:txBody>
+      </p:sp>
+    </p:spTree>
+    <p:extLst>
+      <p:ext uri="{BB962C8B-B14F-4D97-AF65-F5344CB8AC3E}">
+        <p14:creationId xmlns:p14="http://schemas.microsoft.com/office/powerpoint/2010/main" val="1344780025"/>
+      </p:ext>
+    </p:extLst>
+  </p:cSld>
+  <p:clrMapOvr>
+    <a:masterClrMapping/>
+  </p:clrMapOvr>
+</p:sld>
+</file>
+
+<file path=ppt/slides/slide12.xml><?xml version="1.0" encoding="utf-8"?>
+<p:sld xmlns:a="http://schemas.openxmlformats.org/drawingml/2006/main" xmlns:r="http://schemas.openxmlformats.org/officeDocument/2006/relationships" xmlns:p="http://schemas.openxmlformats.org/presentationml/2006/main">
+  <p:cSld>
+    <p:spTree>
+      <p:nvGrpSpPr>
+        <p:cNvPr id="1" name="">
+          <a:extLst>
+            <a:ext uri="{FF2B5EF4-FFF2-40B4-BE49-F238E27FC236}">
+              <a16:creationId xmlns:a16="http://schemas.microsoft.com/office/drawing/2014/main" id="{B8DB3C18-FC53-13EF-926C-75BEC43715ED}"/>
+            </a:ext>
+          </a:extLst>
+        </p:cNvPr>
+        <p:cNvGrpSpPr/>
+        <p:nvPr/>
+      </p:nvGrpSpPr>
+      <p:grpSpPr>
+        <a:xfrm>
+          <a:off x="0" y="0"/>
+          <a:ext cx="0" cy="0"/>
+          <a:chOff x="0" y="0"/>
+          <a:chExt cx="0" cy="0"/>
+        </a:xfrm>
+      </p:grpSpPr>
+      <p:sp>
+        <p:nvSpPr>
+          <p:cNvPr id="2" name="Title 1">
+            <a:extLst>
+              <a:ext uri="{FF2B5EF4-FFF2-40B4-BE49-F238E27FC236}">
+                <a16:creationId xmlns:a16="http://schemas.microsoft.com/office/drawing/2014/main" id="{FF30F48B-A83B-0DFB-C61B-640D608EF200}"/>
+              </a:ext>
+            </a:extLst>
+          </p:cNvPr>
+          <p:cNvSpPr>
+            <a:spLocks noGrp="1"/>
+          </p:cNvSpPr>
+          <p:nvPr>
+            <p:ph type="title"/>
+          </p:nvPr>
+        </p:nvSpPr>
+        <p:spPr/>
+        <p:txBody>
+          <a:bodyPr>
+            <a:normAutofit/>
+          </a:bodyPr>
+          <a:lstStyle/>
+          <a:p>
+            <a:pPr algn="ctr"/>
+            <a:r>
+              <a:rPr lang="en-GB" sz="2800" dirty="0">
+                <a:solidFill>
+                  <a:schemeClr val="bg1"/>
+                </a:solidFill>
+              </a:rPr>
+              <a:t>Website Launch</a:t>
+            </a:r>
+            <a:endParaRPr lang="en-US" sz="2800" dirty="0">
+              <a:solidFill>
+                <a:schemeClr val="bg1"/>
+              </a:solidFill>
+            </a:endParaRPr>
+          </a:p>
+        </p:txBody>
+      </p:sp>
+      <p:sp>
+        <p:nvSpPr>
+          <p:cNvPr id="3" name="Content Placeholder 2">
+            <a:extLst>
+              <a:ext uri="{FF2B5EF4-FFF2-40B4-BE49-F238E27FC236}">
+                <a16:creationId xmlns:a16="http://schemas.microsoft.com/office/drawing/2014/main" id="{7AE37EF8-B4AD-5E42-5113-5044560C1F1F}"/>
+              </a:ext>
+            </a:extLst>
+          </p:cNvPr>
+          <p:cNvSpPr>
+            <a:spLocks noGrp="1"/>
+          </p:cNvSpPr>
+          <p:nvPr>
+            <p:ph idx="1"/>
+          </p:nvPr>
+        </p:nvSpPr>
+        <p:spPr>
+          <a:xfrm>
+            <a:off x="1930879" y="1423059"/>
+            <a:ext cx="8330241" cy="943903"/>
+          </a:xfrm>
+        </p:spPr>
+        <p:txBody>
+          <a:bodyPr vert="horz" lIns="91440" tIns="45720" rIns="91440" bIns="45720" rtlCol="0" anchor="t">
+            <a:normAutofit/>
+          </a:bodyPr>
+          <a:lstStyle/>
+          <a:p>
+            <a:pPr marL="0" indent="0" algn="ctr">
+              <a:buNone/>
+            </a:pPr>
+            <a:r>
+              <a:rPr lang="en-GB" u="sng" dirty="0">
+                <a:solidFill>
+                  <a:schemeClr val="bg1"/>
+                </a:solidFill>
+              </a:rPr>
+              <a:t>Post Launch Support</a:t>
+            </a:r>
+            <a:endParaRPr lang="en-US" u="sng" dirty="0">
+              <a:solidFill>
+                <a:schemeClr val="bg1"/>
+              </a:solidFill>
+            </a:endParaRPr>
+          </a:p>
+        </p:txBody>
+      </p:sp>
+      <p:sp>
+        <p:nvSpPr>
+          <p:cNvPr id="4" name="TextBox 3">
+            <a:extLst>
+              <a:ext uri="{FF2B5EF4-FFF2-40B4-BE49-F238E27FC236}">
+                <a16:creationId xmlns:a16="http://schemas.microsoft.com/office/drawing/2014/main" id="{04FD7B86-07AE-59B0-B7A6-CBE379A8C10A}"/>
+              </a:ext>
+            </a:extLst>
+          </p:cNvPr>
+          <p:cNvSpPr txBox="1"/>
+          <p:nvPr/>
+        </p:nvSpPr>
+        <p:spPr>
+          <a:xfrm>
+            <a:off x="103800" y="3135557"/>
+            <a:ext cx="6021236" cy="2311210"/>
+          </a:xfrm>
+          <a:prstGeom prst="rect">
+            <a:avLst/>
+          </a:prstGeom>
+          <a:noFill/>
+        </p:spPr>
+        <p:txBody>
+          <a:bodyPr rot="0" spcFirstLastPara="0" vertOverflow="overflow" horzOverflow="overflow" vert="horz" wrap="square" lIns="91440" tIns="45720" rIns="91440" bIns="45720" numCol="1" spcCol="0" rtlCol="0" fromWordArt="0" anchor="t" anchorCtr="0" forceAA="0" compatLnSpc="1">
+            <a:prstTxWarp prst="textNoShape">
+              <a:avLst/>
+            </a:prstTxWarp>
+            <a:spAutoFit/>
+          </a:bodyPr>
+          <a:lstStyle/>
+          <a:p>
+            <a:pPr algn="ctr">
+              <a:lnSpc>
+                <a:spcPct val="90000"/>
+              </a:lnSpc>
+              <a:spcBef>
+                <a:spcPts val="1000"/>
+              </a:spcBef>
+            </a:pPr>
+            <a:r>
+              <a:rPr lang="en-GB" sz="3200" dirty="0">
+                <a:solidFill>
+                  <a:schemeClr val="bg1">
+                    <a:lumMod val="75000"/>
+                  </a:schemeClr>
+                </a:solidFill>
+              </a:rPr>
+              <a:t>Technical troubleshooting involving assisting the client if any bugs, unexpected behaviour or website performance related issues are to occur.</a:t>
+            </a:r>
+          </a:p>
+        </p:txBody>
+      </p:sp>
+      <p:sp>
+        <p:nvSpPr>
+          <p:cNvPr id="6" name="TextBox 5">
+            <a:extLst>
+              <a:ext uri="{FF2B5EF4-FFF2-40B4-BE49-F238E27FC236}">
+                <a16:creationId xmlns:a16="http://schemas.microsoft.com/office/drawing/2014/main" id="{01DCB775-2DB6-DA4B-8EFD-E4A542C47DBF}"/>
+              </a:ext>
+            </a:extLst>
+          </p:cNvPr>
+          <p:cNvSpPr txBox="1"/>
+          <p:nvPr/>
+        </p:nvSpPr>
+        <p:spPr>
+          <a:xfrm>
+            <a:off x="6125036" y="3215470"/>
+            <a:ext cx="5661803" cy="1815882"/>
+          </a:xfrm>
+          <a:prstGeom prst="rect">
+            <a:avLst/>
+          </a:prstGeom>
+          <a:noFill/>
+        </p:spPr>
+        <p:txBody>
+          <a:bodyPr rot="0" spcFirstLastPara="0" vertOverflow="overflow" horzOverflow="overflow" vert="horz" wrap="square" lIns="91440" tIns="45720" rIns="91440" bIns="45720" numCol="1" spcCol="0" rtlCol="0" fromWordArt="0" anchor="t" anchorCtr="0" forceAA="0" compatLnSpc="1">
+            <a:prstTxWarp prst="textNoShape">
+              <a:avLst/>
+            </a:prstTxWarp>
+            <a:spAutoFit/>
+          </a:bodyPr>
+          <a:lstStyle/>
+          <a:p>
+            <a:pPr algn="ctr"/>
+            <a:r>
+              <a:rPr lang="en-GB" sz="2800" b="1" u="sng" dirty="0">
+                <a:solidFill>
+                  <a:schemeClr val="bg1"/>
+                </a:solidFill>
+                <a:cs typeface="Segoe UI"/>
+              </a:rPr>
+              <a:t>Content Updates, to the Devon Dive site. This would allow the site to stay dynamic and relevant for returning and future users.</a:t>
+            </a:r>
+          </a:p>
+        </p:txBody>
+      </p:sp>
+    </p:spTree>
+    <p:extLst>
+      <p:ext uri="{BB962C8B-B14F-4D97-AF65-F5344CB8AC3E}">
+        <p14:creationId xmlns:p14="http://schemas.microsoft.com/office/powerpoint/2010/main" val="1566269202"/>
+      </p:ext>
+    </p:extLst>
+  </p:cSld>
+  <p:clrMapOvr>
+    <a:masterClrMapping/>
+  </p:clrMapOvr>
+</p:sld>
+</file>
+
 <file path=ppt/slides/slide2.xml><?xml version="1.0" encoding="utf-8"?>
 <p:sld xmlns:a="http://schemas.openxmlformats.org/drawingml/2006/main" xmlns:r="http://schemas.openxmlformats.org/officeDocument/2006/relationships" xmlns:p="http://schemas.openxmlformats.org/presentationml/2006/main">
   <p:cSld>
@@ -3730,6 +4837,1255 @@
     <p:extLst>
       <p:ext uri="{BB962C8B-B14F-4D97-AF65-F5344CB8AC3E}">
         <p14:creationId xmlns:p14="http://schemas.microsoft.com/office/powerpoint/2010/main" val="3152393514"/>
+      </p:ext>
+    </p:extLst>
+  </p:cSld>
+  <p:clrMapOvr>
+    <a:masterClrMapping/>
+  </p:clrMapOvr>
+</p:sld>
+</file>
+
+<file path=ppt/slides/slide5.xml><?xml version="1.0" encoding="utf-8"?>
+<p:sld xmlns:a="http://schemas.openxmlformats.org/drawingml/2006/main" xmlns:r="http://schemas.openxmlformats.org/officeDocument/2006/relationships" xmlns:p="http://schemas.openxmlformats.org/presentationml/2006/main">
+  <p:cSld>
+    <p:spTree>
+      <p:nvGrpSpPr>
+        <p:cNvPr id="1" name="">
+          <a:extLst>
+            <a:ext uri="{FF2B5EF4-FFF2-40B4-BE49-F238E27FC236}">
+              <a16:creationId xmlns:a16="http://schemas.microsoft.com/office/drawing/2014/main" id="{50A29748-E582-FC43-0FD9-713E261B68FC}"/>
+            </a:ext>
+          </a:extLst>
+        </p:cNvPr>
+        <p:cNvGrpSpPr/>
+        <p:nvPr/>
+      </p:nvGrpSpPr>
+      <p:grpSpPr>
+        <a:xfrm>
+          <a:off x="0" y="0"/>
+          <a:ext cx="0" cy="0"/>
+          <a:chOff x="0" y="0"/>
+          <a:chExt cx="0" cy="0"/>
+        </a:xfrm>
+      </p:grpSpPr>
+      <p:sp>
+        <p:nvSpPr>
+          <p:cNvPr id="2" name="Title 1">
+            <a:extLst>
+              <a:ext uri="{FF2B5EF4-FFF2-40B4-BE49-F238E27FC236}">
+                <a16:creationId xmlns:a16="http://schemas.microsoft.com/office/drawing/2014/main" id="{5B22C14D-3DFE-90D6-0831-A479B2FB90DC}"/>
+              </a:ext>
+            </a:extLst>
+          </p:cNvPr>
+          <p:cNvSpPr>
+            <a:spLocks noGrp="1"/>
+          </p:cNvSpPr>
+          <p:nvPr>
+            <p:ph type="title"/>
+          </p:nvPr>
+        </p:nvSpPr>
+        <p:spPr/>
+        <p:txBody>
+          <a:bodyPr>
+            <a:normAutofit/>
+          </a:bodyPr>
+          <a:lstStyle/>
+          <a:p>
+            <a:pPr algn="ctr"/>
+            <a:r>
+              <a:rPr lang="en-GB" sz="2800" dirty="0">
+                <a:solidFill>
+                  <a:schemeClr val="bg1"/>
+                </a:solidFill>
+              </a:rPr>
+              <a:t>Accessibility</a:t>
+            </a:r>
+            <a:endParaRPr lang="en-US" sz="2800" dirty="0">
+              <a:solidFill>
+                <a:schemeClr val="bg1"/>
+              </a:solidFill>
+            </a:endParaRPr>
+          </a:p>
+        </p:txBody>
+      </p:sp>
+      <p:sp>
+        <p:nvSpPr>
+          <p:cNvPr id="3" name="Content Placeholder 2">
+            <a:extLst>
+              <a:ext uri="{FF2B5EF4-FFF2-40B4-BE49-F238E27FC236}">
+                <a16:creationId xmlns:a16="http://schemas.microsoft.com/office/drawing/2014/main" id="{E0C8F8EA-10A0-0300-086F-0FD781D2FED6}"/>
+              </a:ext>
+            </a:extLst>
+          </p:cNvPr>
+          <p:cNvSpPr>
+            <a:spLocks noGrp="1"/>
+          </p:cNvSpPr>
+          <p:nvPr>
+            <p:ph idx="1"/>
+          </p:nvPr>
+        </p:nvSpPr>
+        <p:spPr>
+          <a:xfrm>
+            <a:off x="1930879" y="1423059"/>
+            <a:ext cx="8330241" cy="943903"/>
+          </a:xfrm>
+        </p:spPr>
+        <p:txBody>
+          <a:bodyPr vert="horz" lIns="91440" tIns="45720" rIns="91440" bIns="45720" rtlCol="0" anchor="t">
+            <a:normAutofit/>
+          </a:bodyPr>
+          <a:lstStyle/>
+          <a:p>
+            <a:pPr marL="0" indent="0" algn="ctr">
+              <a:buNone/>
+            </a:pPr>
+            <a:r>
+              <a:rPr lang="en-US" u="sng" dirty="0">
+                <a:solidFill>
+                  <a:schemeClr val="bg1"/>
+                </a:solidFill>
+              </a:rPr>
+              <a:t>Why it’s important</a:t>
+            </a:r>
+          </a:p>
+        </p:txBody>
+      </p:sp>
+      <p:sp>
+        <p:nvSpPr>
+          <p:cNvPr id="4" name="TextBox 3">
+            <a:extLst>
+              <a:ext uri="{FF2B5EF4-FFF2-40B4-BE49-F238E27FC236}">
+                <a16:creationId xmlns:a16="http://schemas.microsoft.com/office/drawing/2014/main" id="{67B61ADD-3CE3-ADE8-8B97-D4E3090C1C29}"/>
+              </a:ext>
+            </a:extLst>
+          </p:cNvPr>
+          <p:cNvSpPr txBox="1"/>
+          <p:nvPr/>
+        </p:nvSpPr>
+        <p:spPr>
+          <a:xfrm>
+            <a:off x="78493" y="3270267"/>
+            <a:ext cx="6021236" cy="1868012"/>
+          </a:xfrm>
+          <a:prstGeom prst="rect">
+            <a:avLst/>
+          </a:prstGeom>
+          <a:noFill/>
+        </p:spPr>
+        <p:txBody>
+          <a:bodyPr rot="0" spcFirstLastPara="0" vertOverflow="overflow" horzOverflow="overflow" vert="horz" wrap="square" lIns="91440" tIns="45720" rIns="91440" bIns="45720" numCol="1" spcCol="0" rtlCol="0" fromWordArt="0" anchor="t" anchorCtr="0" forceAA="0" compatLnSpc="1">
+            <a:prstTxWarp prst="textNoShape">
+              <a:avLst/>
+            </a:prstTxWarp>
+            <a:spAutoFit/>
+          </a:bodyPr>
+          <a:lstStyle/>
+          <a:p>
+            <a:pPr algn="ctr">
+              <a:lnSpc>
+                <a:spcPct val="90000"/>
+              </a:lnSpc>
+              <a:spcBef>
+                <a:spcPts val="1000"/>
+              </a:spcBef>
+            </a:pPr>
+            <a:r>
+              <a:rPr lang="en-GB" sz="3200" b="1" u="sng" dirty="0">
+                <a:solidFill>
+                  <a:schemeClr val="bg1"/>
+                </a:solidFill>
+              </a:rPr>
+              <a:t>Inclusivity allows you to reach a wider audience of customers you may not have been able to reach before</a:t>
+            </a:r>
+            <a:endParaRPr lang="en-US" sz="3200" b="1" u="sng" dirty="0">
+              <a:solidFill>
+                <a:schemeClr val="bg1"/>
+              </a:solidFill>
+            </a:endParaRPr>
+          </a:p>
+        </p:txBody>
+      </p:sp>
+      <p:sp>
+        <p:nvSpPr>
+          <p:cNvPr id="6" name="TextBox 5">
+            <a:extLst>
+              <a:ext uri="{FF2B5EF4-FFF2-40B4-BE49-F238E27FC236}">
+                <a16:creationId xmlns:a16="http://schemas.microsoft.com/office/drawing/2014/main" id="{FCDF6E62-B506-B00E-3686-2BEDD9071E4E}"/>
+              </a:ext>
+            </a:extLst>
+          </p:cNvPr>
+          <p:cNvSpPr txBox="1"/>
+          <p:nvPr/>
+        </p:nvSpPr>
+        <p:spPr>
+          <a:xfrm>
+            <a:off x="6104626" y="2999116"/>
+            <a:ext cx="5661803" cy="1815882"/>
+          </a:xfrm>
+          <a:prstGeom prst="rect">
+            <a:avLst/>
+          </a:prstGeom>
+          <a:noFill/>
+        </p:spPr>
+        <p:txBody>
+          <a:bodyPr rot="0" spcFirstLastPara="0" vertOverflow="overflow" horzOverflow="overflow" vert="horz" wrap="square" lIns="91440" tIns="45720" rIns="91440" bIns="45720" numCol="1" spcCol="0" rtlCol="0" fromWordArt="0" anchor="t" anchorCtr="0" forceAA="0" compatLnSpc="1">
+            <a:prstTxWarp prst="textNoShape">
+              <a:avLst/>
+            </a:prstTxWarp>
+            <a:spAutoFit/>
+          </a:bodyPr>
+          <a:lstStyle/>
+          <a:p>
+            <a:pPr algn="ctr"/>
+            <a:r>
+              <a:rPr lang="en-GB" sz="2800" dirty="0">
+                <a:solidFill>
+                  <a:schemeClr val="bg1">
+                    <a:lumMod val="76000"/>
+                  </a:schemeClr>
+                </a:solidFill>
+                <a:cs typeface="Segoe UI"/>
+              </a:rPr>
+              <a:t>Accessibility gives you biases within search engines due to improved Search engine optimisation (Ledford, 2020).</a:t>
+            </a:r>
+          </a:p>
+        </p:txBody>
+      </p:sp>
+    </p:spTree>
+    <p:extLst>
+      <p:ext uri="{BB962C8B-B14F-4D97-AF65-F5344CB8AC3E}">
+        <p14:creationId xmlns:p14="http://schemas.microsoft.com/office/powerpoint/2010/main" val="1203612800"/>
+      </p:ext>
+    </p:extLst>
+  </p:cSld>
+  <p:clrMapOvr>
+    <a:masterClrMapping/>
+  </p:clrMapOvr>
+</p:sld>
+</file>
+
+<file path=ppt/slides/slide6.xml><?xml version="1.0" encoding="utf-8"?>
+<p:sld xmlns:a="http://schemas.openxmlformats.org/drawingml/2006/main" xmlns:r="http://schemas.openxmlformats.org/officeDocument/2006/relationships" xmlns:p="http://schemas.openxmlformats.org/presentationml/2006/main">
+  <p:cSld>
+    <p:spTree>
+      <p:nvGrpSpPr>
+        <p:cNvPr id="1" name="">
+          <a:extLst>
+            <a:ext uri="{FF2B5EF4-FFF2-40B4-BE49-F238E27FC236}">
+              <a16:creationId xmlns:a16="http://schemas.microsoft.com/office/drawing/2014/main" id="{C9D406CA-B0EC-76A2-FEAD-FEBE8ED39B10}"/>
+            </a:ext>
+          </a:extLst>
+        </p:cNvPr>
+        <p:cNvGrpSpPr/>
+        <p:nvPr/>
+      </p:nvGrpSpPr>
+      <p:grpSpPr>
+        <a:xfrm>
+          <a:off x="0" y="0"/>
+          <a:ext cx="0" cy="0"/>
+          <a:chOff x="0" y="0"/>
+          <a:chExt cx="0" cy="0"/>
+        </a:xfrm>
+      </p:grpSpPr>
+      <p:sp>
+        <p:nvSpPr>
+          <p:cNvPr id="2" name="Title 1">
+            <a:extLst>
+              <a:ext uri="{FF2B5EF4-FFF2-40B4-BE49-F238E27FC236}">
+                <a16:creationId xmlns:a16="http://schemas.microsoft.com/office/drawing/2014/main" id="{B0F2118B-0B57-4DD2-BEA5-BCAD045203ED}"/>
+              </a:ext>
+            </a:extLst>
+          </p:cNvPr>
+          <p:cNvSpPr>
+            <a:spLocks noGrp="1"/>
+          </p:cNvSpPr>
+          <p:nvPr>
+            <p:ph type="title"/>
+          </p:nvPr>
+        </p:nvSpPr>
+        <p:spPr/>
+        <p:txBody>
+          <a:bodyPr>
+            <a:normAutofit/>
+          </a:bodyPr>
+          <a:lstStyle/>
+          <a:p>
+            <a:pPr algn="ctr"/>
+            <a:r>
+              <a:rPr lang="en-GB" sz="2800" dirty="0">
+                <a:solidFill>
+                  <a:schemeClr val="bg1"/>
+                </a:solidFill>
+              </a:rPr>
+              <a:t>Accessibility</a:t>
+            </a:r>
+            <a:endParaRPr lang="en-US" sz="2800" dirty="0">
+              <a:solidFill>
+                <a:schemeClr val="bg1"/>
+              </a:solidFill>
+            </a:endParaRPr>
+          </a:p>
+        </p:txBody>
+      </p:sp>
+      <p:sp>
+        <p:nvSpPr>
+          <p:cNvPr id="3" name="Content Placeholder 2">
+            <a:extLst>
+              <a:ext uri="{FF2B5EF4-FFF2-40B4-BE49-F238E27FC236}">
+                <a16:creationId xmlns:a16="http://schemas.microsoft.com/office/drawing/2014/main" id="{025D3B64-7FE5-0C5A-F9A9-45A78B92AB80}"/>
+              </a:ext>
+            </a:extLst>
+          </p:cNvPr>
+          <p:cNvSpPr>
+            <a:spLocks noGrp="1"/>
+          </p:cNvSpPr>
+          <p:nvPr>
+            <p:ph idx="1"/>
+          </p:nvPr>
+        </p:nvSpPr>
+        <p:spPr>
+          <a:xfrm>
+            <a:off x="1930879" y="1423059"/>
+            <a:ext cx="8330241" cy="943903"/>
+          </a:xfrm>
+        </p:spPr>
+        <p:txBody>
+          <a:bodyPr vert="horz" lIns="91440" tIns="45720" rIns="91440" bIns="45720" rtlCol="0" anchor="t">
+            <a:normAutofit/>
+          </a:bodyPr>
+          <a:lstStyle/>
+          <a:p>
+            <a:pPr marL="0" indent="0" algn="ctr">
+              <a:buNone/>
+            </a:pPr>
+            <a:r>
+              <a:rPr lang="en-US" u="sng" dirty="0">
+                <a:solidFill>
+                  <a:schemeClr val="bg1"/>
+                </a:solidFill>
+              </a:rPr>
+              <a:t>Why it’s important</a:t>
+            </a:r>
+          </a:p>
+        </p:txBody>
+      </p:sp>
+      <p:sp>
+        <p:nvSpPr>
+          <p:cNvPr id="4" name="TextBox 3">
+            <a:extLst>
+              <a:ext uri="{FF2B5EF4-FFF2-40B4-BE49-F238E27FC236}">
+                <a16:creationId xmlns:a16="http://schemas.microsoft.com/office/drawing/2014/main" id="{B8FD4CE6-2827-8FB1-C685-42F52A69406F}"/>
+              </a:ext>
+            </a:extLst>
+          </p:cNvPr>
+          <p:cNvSpPr txBox="1"/>
+          <p:nvPr/>
+        </p:nvSpPr>
+        <p:spPr>
+          <a:xfrm>
+            <a:off x="103800" y="3135557"/>
+            <a:ext cx="6021236" cy="1868012"/>
+          </a:xfrm>
+          <a:prstGeom prst="rect">
+            <a:avLst/>
+          </a:prstGeom>
+          <a:noFill/>
+        </p:spPr>
+        <p:txBody>
+          <a:bodyPr rot="0" spcFirstLastPara="0" vertOverflow="overflow" horzOverflow="overflow" vert="horz" wrap="square" lIns="91440" tIns="45720" rIns="91440" bIns="45720" numCol="1" spcCol="0" rtlCol="0" fromWordArt="0" anchor="t" anchorCtr="0" forceAA="0" compatLnSpc="1">
+            <a:prstTxWarp prst="textNoShape">
+              <a:avLst/>
+            </a:prstTxWarp>
+            <a:spAutoFit/>
+          </a:bodyPr>
+          <a:lstStyle/>
+          <a:p>
+            <a:pPr algn="ctr">
+              <a:lnSpc>
+                <a:spcPct val="90000"/>
+              </a:lnSpc>
+              <a:spcBef>
+                <a:spcPts val="1000"/>
+              </a:spcBef>
+            </a:pPr>
+            <a:r>
+              <a:rPr lang="en-GB" sz="3200" dirty="0">
+                <a:solidFill>
+                  <a:schemeClr val="bg1">
+                    <a:lumMod val="75000"/>
+                  </a:schemeClr>
+                </a:solidFill>
+              </a:rPr>
+              <a:t>Inclusivity allows you to reach a wider audience of customers you may not have been able to reach before.</a:t>
+            </a:r>
+            <a:endParaRPr lang="en-US" sz="3200" dirty="0">
+              <a:solidFill>
+                <a:schemeClr val="bg1">
+                  <a:lumMod val="75000"/>
+                </a:schemeClr>
+              </a:solidFill>
+            </a:endParaRPr>
+          </a:p>
+        </p:txBody>
+      </p:sp>
+      <p:sp>
+        <p:nvSpPr>
+          <p:cNvPr id="6" name="TextBox 5">
+            <a:extLst>
+              <a:ext uri="{FF2B5EF4-FFF2-40B4-BE49-F238E27FC236}">
+                <a16:creationId xmlns:a16="http://schemas.microsoft.com/office/drawing/2014/main" id="{16B4AC2D-E5E3-3FE5-F8F5-A351E771BDB7}"/>
+              </a:ext>
+            </a:extLst>
+          </p:cNvPr>
+          <p:cNvSpPr txBox="1"/>
+          <p:nvPr/>
+        </p:nvSpPr>
+        <p:spPr>
+          <a:xfrm>
+            <a:off x="6125036" y="3084841"/>
+            <a:ext cx="5661803" cy="1877437"/>
+          </a:xfrm>
+          <a:prstGeom prst="rect">
+            <a:avLst/>
+          </a:prstGeom>
+          <a:noFill/>
+        </p:spPr>
+        <p:txBody>
+          <a:bodyPr rot="0" spcFirstLastPara="0" vertOverflow="overflow" horzOverflow="overflow" vert="horz" wrap="square" lIns="91440" tIns="45720" rIns="91440" bIns="45720" numCol="1" spcCol="0" rtlCol="0" fromWordArt="0" anchor="t" anchorCtr="0" forceAA="0" compatLnSpc="1">
+            <a:prstTxWarp prst="textNoShape">
+              <a:avLst/>
+            </a:prstTxWarp>
+            <a:spAutoFit/>
+          </a:bodyPr>
+          <a:lstStyle/>
+          <a:p>
+            <a:pPr algn="ctr"/>
+            <a:r>
+              <a:rPr lang="en-GB" sz="2800" b="1" u="sng" dirty="0">
+                <a:solidFill>
+                  <a:schemeClr val="bg1"/>
+                </a:solidFill>
+                <a:cs typeface="Segoe UI"/>
+              </a:rPr>
+              <a:t>Accessibility gives you biases within </a:t>
+            </a:r>
+            <a:r>
+              <a:rPr lang="en-GB" sz="3200" b="1" u="sng" dirty="0">
+                <a:solidFill>
+                  <a:schemeClr val="bg1"/>
+                </a:solidFill>
+                <a:cs typeface="Segoe UI"/>
+              </a:rPr>
+              <a:t>search</a:t>
+            </a:r>
+            <a:r>
+              <a:rPr lang="en-GB" sz="2800" b="1" u="sng" dirty="0">
+                <a:solidFill>
+                  <a:schemeClr val="bg1"/>
+                </a:solidFill>
+                <a:cs typeface="Segoe UI"/>
+              </a:rPr>
+              <a:t> engines due to Search engine optimisation (Ledford, 2020).</a:t>
+            </a:r>
+          </a:p>
+        </p:txBody>
+      </p:sp>
+    </p:spTree>
+    <p:extLst>
+      <p:ext uri="{BB962C8B-B14F-4D97-AF65-F5344CB8AC3E}">
+        <p14:creationId xmlns:p14="http://schemas.microsoft.com/office/powerpoint/2010/main" val="772271153"/>
+      </p:ext>
+    </p:extLst>
+  </p:cSld>
+  <p:clrMapOvr>
+    <a:masterClrMapping/>
+  </p:clrMapOvr>
+</p:sld>
+</file>
+
+<file path=ppt/slides/slide7.xml><?xml version="1.0" encoding="utf-8"?>
+<p:sld xmlns:a="http://schemas.openxmlformats.org/drawingml/2006/main" xmlns:r="http://schemas.openxmlformats.org/officeDocument/2006/relationships" xmlns:p="http://schemas.openxmlformats.org/presentationml/2006/main">
+  <p:cSld>
+    <p:spTree>
+      <p:nvGrpSpPr>
+        <p:cNvPr id="1" name="">
+          <a:extLst>
+            <a:ext uri="{FF2B5EF4-FFF2-40B4-BE49-F238E27FC236}">
+              <a16:creationId xmlns:a16="http://schemas.microsoft.com/office/drawing/2014/main" id="{6E03C457-A7AA-A0E7-4ED5-D3CDA1E6C1C8}"/>
+            </a:ext>
+          </a:extLst>
+        </p:cNvPr>
+        <p:cNvGrpSpPr/>
+        <p:nvPr/>
+      </p:nvGrpSpPr>
+      <p:grpSpPr>
+        <a:xfrm>
+          <a:off x="0" y="0"/>
+          <a:ext cx="0" cy="0"/>
+          <a:chOff x="0" y="0"/>
+          <a:chExt cx="0" cy="0"/>
+        </a:xfrm>
+      </p:grpSpPr>
+      <p:sp>
+        <p:nvSpPr>
+          <p:cNvPr id="2" name="Title 1">
+            <a:extLst>
+              <a:ext uri="{FF2B5EF4-FFF2-40B4-BE49-F238E27FC236}">
+                <a16:creationId xmlns:a16="http://schemas.microsoft.com/office/drawing/2014/main" id="{B28EC88C-8156-E2F1-A049-B6DD21E06CFA}"/>
+              </a:ext>
+            </a:extLst>
+          </p:cNvPr>
+          <p:cNvSpPr>
+            <a:spLocks noGrp="1"/>
+          </p:cNvSpPr>
+          <p:nvPr>
+            <p:ph type="title"/>
+          </p:nvPr>
+        </p:nvSpPr>
+        <p:spPr/>
+        <p:txBody>
+          <a:bodyPr>
+            <a:normAutofit/>
+          </a:bodyPr>
+          <a:lstStyle/>
+          <a:p>
+            <a:pPr algn="ctr"/>
+            <a:r>
+              <a:rPr lang="en-GB" sz="2800" dirty="0">
+                <a:solidFill>
+                  <a:schemeClr val="bg1"/>
+                </a:solidFill>
+              </a:rPr>
+              <a:t>Accessibility</a:t>
+            </a:r>
+            <a:endParaRPr lang="en-US" sz="2800" dirty="0">
+              <a:solidFill>
+                <a:schemeClr val="bg1"/>
+              </a:solidFill>
+            </a:endParaRPr>
+          </a:p>
+        </p:txBody>
+      </p:sp>
+      <p:sp>
+        <p:nvSpPr>
+          <p:cNvPr id="3" name="Content Placeholder 2">
+            <a:extLst>
+              <a:ext uri="{FF2B5EF4-FFF2-40B4-BE49-F238E27FC236}">
+                <a16:creationId xmlns:a16="http://schemas.microsoft.com/office/drawing/2014/main" id="{94839316-46C1-EFC7-2E25-3B99EE3E2EA9}"/>
+              </a:ext>
+            </a:extLst>
+          </p:cNvPr>
+          <p:cNvSpPr>
+            <a:spLocks noGrp="1"/>
+          </p:cNvSpPr>
+          <p:nvPr>
+            <p:ph idx="1"/>
+          </p:nvPr>
+        </p:nvSpPr>
+        <p:spPr>
+          <a:xfrm>
+            <a:off x="1930879" y="1423059"/>
+            <a:ext cx="8330241" cy="943903"/>
+          </a:xfrm>
+        </p:spPr>
+        <p:txBody>
+          <a:bodyPr vert="horz" lIns="91440" tIns="45720" rIns="91440" bIns="45720" rtlCol="0" anchor="t">
+            <a:normAutofit/>
+          </a:bodyPr>
+          <a:lstStyle/>
+          <a:p>
+            <a:pPr marL="0" indent="0" algn="ctr">
+              <a:buNone/>
+            </a:pPr>
+            <a:r>
+              <a:rPr lang="en-US" u="sng" dirty="0">
+                <a:solidFill>
+                  <a:schemeClr val="bg1"/>
+                </a:solidFill>
+              </a:rPr>
+              <a:t>How to be accessible</a:t>
+            </a:r>
+          </a:p>
+        </p:txBody>
+      </p:sp>
+      <p:sp>
+        <p:nvSpPr>
+          <p:cNvPr id="4" name="TextBox 3">
+            <a:extLst>
+              <a:ext uri="{FF2B5EF4-FFF2-40B4-BE49-F238E27FC236}">
+                <a16:creationId xmlns:a16="http://schemas.microsoft.com/office/drawing/2014/main" id="{2E09CB2F-8D15-251C-C391-10974463CE37}"/>
+              </a:ext>
+            </a:extLst>
+          </p:cNvPr>
+          <p:cNvSpPr txBox="1"/>
+          <p:nvPr/>
+        </p:nvSpPr>
+        <p:spPr>
+          <a:xfrm>
+            <a:off x="78493" y="3270267"/>
+            <a:ext cx="6021236" cy="3325847"/>
+          </a:xfrm>
+          <a:prstGeom prst="rect">
+            <a:avLst/>
+          </a:prstGeom>
+          <a:noFill/>
+        </p:spPr>
+        <p:txBody>
+          <a:bodyPr rot="0" spcFirstLastPara="0" vertOverflow="overflow" horzOverflow="overflow" vert="horz" wrap="square" lIns="91440" tIns="45720" rIns="91440" bIns="45720" numCol="1" spcCol="0" rtlCol="0" fromWordArt="0" anchor="t" anchorCtr="0" forceAA="0" compatLnSpc="1">
+            <a:prstTxWarp prst="textNoShape">
+              <a:avLst/>
+            </a:prstTxWarp>
+            <a:spAutoFit/>
+          </a:bodyPr>
+          <a:lstStyle/>
+          <a:p>
+            <a:pPr algn="ctr">
+              <a:lnSpc>
+                <a:spcPct val="90000"/>
+              </a:lnSpc>
+              <a:spcBef>
+                <a:spcPts val="1000"/>
+              </a:spcBef>
+            </a:pPr>
+            <a:r>
+              <a:rPr lang="en-GB" sz="3200" b="1" u="sng" dirty="0">
+                <a:solidFill>
+                  <a:schemeClr val="bg1"/>
+                </a:solidFill>
+              </a:rPr>
+              <a:t>Following the Web Content Accessibility Guidelines. This is a set of internationally accepted guidelines for web development </a:t>
+            </a:r>
+          </a:p>
+          <a:p>
+            <a:pPr algn="ctr">
+              <a:lnSpc>
+                <a:spcPct val="90000"/>
+              </a:lnSpc>
+              <a:spcBef>
+                <a:spcPts val="1000"/>
+              </a:spcBef>
+            </a:pPr>
+            <a:r>
+              <a:rPr lang="en-GB" sz="3200" b="1" u="sng" dirty="0">
+                <a:solidFill>
+                  <a:schemeClr val="bg1"/>
+                </a:solidFill>
+              </a:rPr>
+              <a:t>(World wide Web Consortium, 2018)</a:t>
+            </a:r>
+            <a:endParaRPr lang="en-US" sz="3200" b="1" u="sng" dirty="0">
+              <a:solidFill>
+                <a:schemeClr val="bg1"/>
+              </a:solidFill>
+            </a:endParaRPr>
+          </a:p>
+        </p:txBody>
+      </p:sp>
+      <p:sp>
+        <p:nvSpPr>
+          <p:cNvPr id="6" name="TextBox 5">
+            <a:extLst>
+              <a:ext uri="{FF2B5EF4-FFF2-40B4-BE49-F238E27FC236}">
+                <a16:creationId xmlns:a16="http://schemas.microsoft.com/office/drawing/2014/main" id="{81B6BD22-0D66-117F-F3F5-331298964F67}"/>
+              </a:ext>
+            </a:extLst>
+          </p:cNvPr>
+          <p:cNvSpPr txBox="1"/>
+          <p:nvPr/>
+        </p:nvSpPr>
+        <p:spPr>
+          <a:xfrm>
+            <a:off x="6104626" y="2999116"/>
+            <a:ext cx="5661803" cy="2677656"/>
+          </a:xfrm>
+          <a:prstGeom prst="rect">
+            <a:avLst/>
+          </a:prstGeom>
+          <a:noFill/>
+        </p:spPr>
+        <p:txBody>
+          <a:bodyPr rot="0" spcFirstLastPara="0" vertOverflow="overflow" horzOverflow="overflow" vert="horz" wrap="square" lIns="91440" tIns="45720" rIns="91440" bIns="45720" numCol="1" spcCol="0" rtlCol="0" fromWordArt="0" anchor="t" anchorCtr="0" forceAA="0" compatLnSpc="1">
+            <a:prstTxWarp prst="textNoShape">
+              <a:avLst/>
+            </a:prstTxWarp>
+            <a:spAutoFit/>
+          </a:bodyPr>
+          <a:lstStyle/>
+          <a:p>
+            <a:pPr algn="ctr"/>
+            <a:r>
+              <a:rPr lang="en-GB" sz="2800" dirty="0">
+                <a:solidFill>
+                  <a:schemeClr val="bg1">
+                    <a:lumMod val="65000"/>
+                  </a:schemeClr>
+                </a:solidFill>
+                <a:effectLst/>
+                <a:ea typeface="Aptos" panose="020B0004020202020204" pitchFamily="34" charset="0"/>
+                <a:cs typeface="Times New Roman" panose="02020603050405020304" pitchFamily="18" charset="0"/>
+              </a:rPr>
+              <a:t>POUR: perceivable, operable, understandable and robust</a:t>
+            </a:r>
+            <a:br>
+              <a:rPr lang="en-GB" sz="2800" dirty="0">
+                <a:solidFill>
+                  <a:schemeClr val="bg1">
+                    <a:lumMod val="65000"/>
+                  </a:schemeClr>
+                </a:solidFill>
+                <a:effectLst/>
+                <a:ea typeface="Aptos" panose="020B0004020202020204" pitchFamily="34" charset="0"/>
+                <a:cs typeface="Times New Roman" panose="02020603050405020304" pitchFamily="18" charset="0"/>
+              </a:rPr>
+            </a:br>
+            <a:br>
+              <a:rPr lang="en-GB" sz="2800" dirty="0">
+                <a:solidFill>
+                  <a:schemeClr val="bg1">
+                    <a:lumMod val="65000"/>
+                  </a:schemeClr>
+                </a:solidFill>
+                <a:effectLst/>
+                <a:ea typeface="Aptos" panose="020B0004020202020204" pitchFamily="34" charset="0"/>
+                <a:cs typeface="Times New Roman" panose="02020603050405020304" pitchFamily="18" charset="0"/>
+              </a:rPr>
+            </a:br>
+            <a:r>
+              <a:rPr lang="en-GB" sz="2800" dirty="0">
+                <a:solidFill>
+                  <a:schemeClr val="bg1">
+                    <a:lumMod val="65000"/>
+                  </a:schemeClr>
+                </a:solidFill>
+                <a:effectLst/>
+                <a:ea typeface="Aptos" panose="020B0004020202020204" pitchFamily="34" charset="0"/>
+                <a:cs typeface="Times New Roman" panose="02020603050405020304" pitchFamily="18" charset="0"/>
+              </a:rPr>
+              <a:t>ARIA: Accessible rich Internet Applications</a:t>
+            </a:r>
+          </a:p>
+          <a:p>
+            <a:pPr algn="ctr"/>
+            <a:r>
+              <a:rPr lang="en-GB" sz="2800" dirty="0">
+                <a:solidFill>
+                  <a:schemeClr val="bg1">
+                    <a:lumMod val="65000"/>
+                  </a:schemeClr>
+                </a:solidFill>
+                <a:effectLst/>
+                <a:ea typeface="Aptos" panose="020B0004020202020204" pitchFamily="34" charset="0"/>
+                <a:cs typeface="Times New Roman" panose="02020603050405020304" pitchFamily="18" charset="0"/>
+              </a:rPr>
+              <a:t> </a:t>
+            </a:r>
+            <a:endParaRPr lang="en-GB" sz="2800" dirty="0">
+              <a:solidFill>
+                <a:schemeClr val="bg1">
+                  <a:lumMod val="65000"/>
+                </a:schemeClr>
+              </a:solidFill>
+              <a:cs typeface="Segoe UI"/>
+            </a:endParaRPr>
+          </a:p>
+        </p:txBody>
+      </p:sp>
+    </p:spTree>
+    <p:extLst>
+      <p:ext uri="{BB962C8B-B14F-4D97-AF65-F5344CB8AC3E}">
+        <p14:creationId xmlns:p14="http://schemas.microsoft.com/office/powerpoint/2010/main" val="3014033896"/>
+      </p:ext>
+    </p:extLst>
+  </p:cSld>
+  <p:clrMapOvr>
+    <a:masterClrMapping/>
+  </p:clrMapOvr>
+</p:sld>
+</file>
+
+<file path=ppt/slides/slide8.xml><?xml version="1.0" encoding="utf-8"?>
+<p:sld xmlns:a="http://schemas.openxmlformats.org/drawingml/2006/main" xmlns:r="http://schemas.openxmlformats.org/officeDocument/2006/relationships" xmlns:p="http://schemas.openxmlformats.org/presentationml/2006/main">
+  <p:cSld>
+    <p:spTree>
+      <p:nvGrpSpPr>
+        <p:cNvPr id="1" name="">
+          <a:extLst>
+            <a:ext uri="{FF2B5EF4-FFF2-40B4-BE49-F238E27FC236}">
+              <a16:creationId xmlns:a16="http://schemas.microsoft.com/office/drawing/2014/main" id="{037B2F9D-C0E8-C10A-98D7-DECA1842B54C}"/>
+            </a:ext>
+          </a:extLst>
+        </p:cNvPr>
+        <p:cNvGrpSpPr/>
+        <p:nvPr/>
+      </p:nvGrpSpPr>
+      <p:grpSpPr>
+        <a:xfrm>
+          <a:off x="0" y="0"/>
+          <a:ext cx="0" cy="0"/>
+          <a:chOff x="0" y="0"/>
+          <a:chExt cx="0" cy="0"/>
+        </a:xfrm>
+      </p:grpSpPr>
+      <p:sp>
+        <p:nvSpPr>
+          <p:cNvPr id="2" name="Title 1">
+            <a:extLst>
+              <a:ext uri="{FF2B5EF4-FFF2-40B4-BE49-F238E27FC236}">
+                <a16:creationId xmlns:a16="http://schemas.microsoft.com/office/drawing/2014/main" id="{7D5DBE4E-11DF-0AE6-A8E1-750283FFFDBF}"/>
+              </a:ext>
+            </a:extLst>
+          </p:cNvPr>
+          <p:cNvSpPr>
+            <a:spLocks noGrp="1"/>
+          </p:cNvSpPr>
+          <p:nvPr>
+            <p:ph type="title"/>
+          </p:nvPr>
+        </p:nvSpPr>
+        <p:spPr/>
+        <p:txBody>
+          <a:bodyPr>
+            <a:normAutofit/>
+          </a:bodyPr>
+          <a:lstStyle/>
+          <a:p>
+            <a:pPr algn="ctr"/>
+            <a:r>
+              <a:rPr lang="en-GB" sz="2800" dirty="0">
+                <a:solidFill>
+                  <a:schemeClr val="bg1"/>
+                </a:solidFill>
+              </a:rPr>
+              <a:t>Accessibility</a:t>
+            </a:r>
+            <a:endParaRPr lang="en-US" sz="2800" dirty="0">
+              <a:solidFill>
+                <a:schemeClr val="bg1"/>
+              </a:solidFill>
+            </a:endParaRPr>
+          </a:p>
+        </p:txBody>
+      </p:sp>
+      <p:sp>
+        <p:nvSpPr>
+          <p:cNvPr id="3" name="Content Placeholder 2">
+            <a:extLst>
+              <a:ext uri="{FF2B5EF4-FFF2-40B4-BE49-F238E27FC236}">
+                <a16:creationId xmlns:a16="http://schemas.microsoft.com/office/drawing/2014/main" id="{130FD06A-AA13-4474-576E-2DC9FA51CE60}"/>
+              </a:ext>
+            </a:extLst>
+          </p:cNvPr>
+          <p:cNvSpPr>
+            <a:spLocks noGrp="1"/>
+          </p:cNvSpPr>
+          <p:nvPr>
+            <p:ph idx="1"/>
+          </p:nvPr>
+        </p:nvSpPr>
+        <p:spPr>
+          <a:xfrm>
+            <a:off x="1930879" y="1423059"/>
+            <a:ext cx="8330241" cy="943903"/>
+          </a:xfrm>
+        </p:spPr>
+        <p:txBody>
+          <a:bodyPr vert="horz" lIns="91440" tIns="45720" rIns="91440" bIns="45720" rtlCol="0" anchor="t">
+            <a:normAutofit/>
+          </a:bodyPr>
+          <a:lstStyle/>
+          <a:p>
+            <a:pPr marL="0" indent="0" algn="ctr">
+              <a:buNone/>
+            </a:pPr>
+            <a:r>
+              <a:rPr lang="en-US" u="sng" dirty="0">
+                <a:solidFill>
+                  <a:schemeClr val="bg1"/>
+                </a:solidFill>
+              </a:rPr>
+              <a:t>How to be accessible</a:t>
+            </a:r>
+          </a:p>
+        </p:txBody>
+      </p:sp>
+      <p:sp>
+        <p:nvSpPr>
+          <p:cNvPr id="4" name="TextBox 3">
+            <a:extLst>
+              <a:ext uri="{FF2B5EF4-FFF2-40B4-BE49-F238E27FC236}">
+                <a16:creationId xmlns:a16="http://schemas.microsoft.com/office/drawing/2014/main" id="{BC9A4955-391E-193E-3601-23201BC24F12}"/>
+              </a:ext>
+            </a:extLst>
+          </p:cNvPr>
+          <p:cNvSpPr txBox="1"/>
+          <p:nvPr/>
+        </p:nvSpPr>
+        <p:spPr>
+          <a:xfrm>
+            <a:off x="103800" y="3135557"/>
+            <a:ext cx="6021236" cy="2882649"/>
+          </a:xfrm>
+          <a:prstGeom prst="rect">
+            <a:avLst/>
+          </a:prstGeom>
+          <a:noFill/>
+        </p:spPr>
+        <p:txBody>
+          <a:bodyPr rot="0" spcFirstLastPara="0" vertOverflow="overflow" horzOverflow="overflow" vert="horz" wrap="square" lIns="91440" tIns="45720" rIns="91440" bIns="45720" numCol="1" spcCol="0" rtlCol="0" fromWordArt="0" anchor="t" anchorCtr="0" forceAA="0" compatLnSpc="1">
+            <a:prstTxWarp prst="textNoShape">
+              <a:avLst/>
+            </a:prstTxWarp>
+            <a:spAutoFit/>
+          </a:bodyPr>
+          <a:lstStyle/>
+          <a:p>
+            <a:pPr algn="ctr">
+              <a:lnSpc>
+                <a:spcPct val="90000"/>
+              </a:lnSpc>
+              <a:spcBef>
+                <a:spcPts val="1000"/>
+              </a:spcBef>
+            </a:pPr>
+            <a:r>
+              <a:rPr lang="en-GB" sz="3200" dirty="0">
+                <a:solidFill>
+                  <a:schemeClr val="bg1">
+                    <a:lumMod val="75000"/>
+                  </a:schemeClr>
+                </a:solidFill>
+              </a:rPr>
+              <a:t>Following the Web Content Accessibility Guidelines. This is a set of internationally accepted guidelines for web development </a:t>
+            </a:r>
+          </a:p>
+          <a:p>
+            <a:pPr algn="ctr">
+              <a:lnSpc>
+                <a:spcPct val="90000"/>
+              </a:lnSpc>
+              <a:spcBef>
+                <a:spcPts val="1000"/>
+              </a:spcBef>
+            </a:pPr>
+            <a:r>
+              <a:rPr lang="en-GB" sz="3200" dirty="0">
+                <a:solidFill>
+                  <a:schemeClr val="bg1">
+                    <a:lumMod val="75000"/>
+                  </a:schemeClr>
+                </a:solidFill>
+              </a:rPr>
+              <a:t>(World wide Web Consortium, 2018)</a:t>
+            </a:r>
+          </a:p>
+        </p:txBody>
+      </p:sp>
+      <p:sp>
+        <p:nvSpPr>
+          <p:cNvPr id="6" name="TextBox 5">
+            <a:extLst>
+              <a:ext uri="{FF2B5EF4-FFF2-40B4-BE49-F238E27FC236}">
+                <a16:creationId xmlns:a16="http://schemas.microsoft.com/office/drawing/2014/main" id="{296340F2-9141-9B03-0675-744B31667F88}"/>
+              </a:ext>
+            </a:extLst>
+          </p:cNvPr>
+          <p:cNvSpPr txBox="1"/>
+          <p:nvPr/>
+        </p:nvSpPr>
+        <p:spPr>
+          <a:xfrm>
+            <a:off x="6125036" y="3084841"/>
+            <a:ext cx="5661803" cy="2246769"/>
+          </a:xfrm>
+          <a:prstGeom prst="rect">
+            <a:avLst/>
+          </a:prstGeom>
+          <a:noFill/>
+        </p:spPr>
+        <p:txBody>
+          <a:bodyPr rot="0" spcFirstLastPara="0" vertOverflow="overflow" horzOverflow="overflow" vert="horz" wrap="square" lIns="91440" tIns="45720" rIns="91440" bIns="45720" numCol="1" spcCol="0" rtlCol="0" fromWordArt="0" anchor="t" anchorCtr="0" forceAA="0" compatLnSpc="1">
+            <a:prstTxWarp prst="textNoShape">
+              <a:avLst/>
+            </a:prstTxWarp>
+            <a:spAutoFit/>
+          </a:bodyPr>
+          <a:lstStyle/>
+          <a:p>
+            <a:pPr algn="ctr"/>
+            <a:r>
+              <a:rPr lang="en-GB" sz="2800" b="1" u="sng" dirty="0">
+                <a:solidFill>
+                  <a:schemeClr val="bg1"/>
+                </a:solidFill>
+                <a:cs typeface="Segoe UI"/>
+              </a:rPr>
+              <a:t>POUR: perceivable, operable, understandable and robust</a:t>
+            </a:r>
+            <a:br>
+              <a:rPr lang="en-GB" sz="2800" b="1" u="sng" dirty="0">
+                <a:solidFill>
+                  <a:schemeClr val="bg1"/>
+                </a:solidFill>
+                <a:cs typeface="Segoe UI"/>
+              </a:rPr>
+            </a:br>
+            <a:br>
+              <a:rPr lang="en-GB" sz="2800" b="1" u="sng" dirty="0">
+                <a:solidFill>
+                  <a:schemeClr val="bg1"/>
+                </a:solidFill>
+                <a:cs typeface="Segoe UI"/>
+              </a:rPr>
+            </a:br>
+            <a:r>
+              <a:rPr lang="en-GB" sz="2800" b="1" u="sng" dirty="0">
+                <a:solidFill>
+                  <a:schemeClr val="bg1"/>
+                </a:solidFill>
+                <a:cs typeface="Segoe UI"/>
+              </a:rPr>
+              <a:t>ARIA: Accessible rich Internet Applications</a:t>
+            </a:r>
+          </a:p>
+        </p:txBody>
+      </p:sp>
+    </p:spTree>
+    <p:extLst>
+      <p:ext uri="{BB962C8B-B14F-4D97-AF65-F5344CB8AC3E}">
+        <p14:creationId xmlns:p14="http://schemas.microsoft.com/office/powerpoint/2010/main" val="1601793062"/>
+      </p:ext>
+    </p:extLst>
+  </p:cSld>
+  <p:clrMapOvr>
+    <a:masterClrMapping/>
+  </p:clrMapOvr>
+</p:sld>
+</file>
+
+<file path=ppt/slides/slide9.xml><?xml version="1.0" encoding="utf-8"?>
+<p:sld xmlns:a="http://schemas.openxmlformats.org/drawingml/2006/main" xmlns:r="http://schemas.openxmlformats.org/officeDocument/2006/relationships" xmlns:p="http://schemas.openxmlformats.org/presentationml/2006/main">
+  <p:cSld>
+    <p:spTree>
+      <p:nvGrpSpPr>
+        <p:cNvPr id="1" name="">
+          <a:extLst>
+            <a:ext uri="{FF2B5EF4-FFF2-40B4-BE49-F238E27FC236}">
+              <a16:creationId xmlns:a16="http://schemas.microsoft.com/office/drawing/2014/main" id="{3DA16A14-303B-0848-86E8-9C9DAC0ECDD4}"/>
+            </a:ext>
+          </a:extLst>
+        </p:cNvPr>
+        <p:cNvGrpSpPr/>
+        <p:nvPr/>
+      </p:nvGrpSpPr>
+      <p:grpSpPr>
+        <a:xfrm>
+          <a:off x="0" y="0"/>
+          <a:ext cx="0" cy="0"/>
+          <a:chOff x="0" y="0"/>
+          <a:chExt cx="0" cy="0"/>
+        </a:xfrm>
+      </p:grpSpPr>
+      <p:sp>
+        <p:nvSpPr>
+          <p:cNvPr id="2" name="Title 1">
+            <a:extLst>
+              <a:ext uri="{FF2B5EF4-FFF2-40B4-BE49-F238E27FC236}">
+                <a16:creationId xmlns:a16="http://schemas.microsoft.com/office/drawing/2014/main" id="{D398A211-4AB0-D9D8-859B-3E582A6D02A7}"/>
+              </a:ext>
+            </a:extLst>
+          </p:cNvPr>
+          <p:cNvSpPr>
+            <a:spLocks noGrp="1"/>
+          </p:cNvSpPr>
+          <p:nvPr>
+            <p:ph type="title"/>
+          </p:nvPr>
+        </p:nvSpPr>
+        <p:spPr/>
+        <p:txBody>
+          <a:bodyPr>
+            <a:normAutofit/>
+          </a:bodyPr>
+          <a:lstStyle/>
+          <a:p>
+            <a:pPr algn="ctr"/>
+            <a:r>
+              <a:rPr lang="en-GB" sz="2800" dirty="0">
+                <a:solidFill>
+                  <a:schemeClr val="bg1"/>
+                </a:solidFill>
+              </a:rPr>
+              <a:t>Website Launch</a:t>
+            </a:r>
+            <a:endParaRPr lang="en-US" sz="2800" dirty="0">
+              <a:solidFill>
+                <a:schemeClr val="bg1"/>
+              </a:solidFill>
+            </a:endParaRPr>
+          </a:p>
+        </p:txBody>
+      </p:sp>
+      <p:sp>
+        <p:nvSpPr>
+          <p:cNvPr id="3" name="Content Placeholder 2">
+            <a:extLst>
+              <a:ext uri="{FF2B5EF4-FFF2-40B4-BE49-F238E27FC236}">
+                <a16:creationId xmlns:a16="http://schemas.microsoft.com/office/drawing/2014/main" id="{936CE0F2-E360-9B9E-25D0-2D4B9ED8C23D}"/>
+              </a:ext>
+            </a:extLst>
+          </p:cNvPr>
+          <p:cNvSpPr>
+            <a:spLocks noGrp="1"/>
+          </p:cNvSpPr>
+          <p:nvPr>
+            <p:ph idx="1"/>
+          </p:nvPr>
+        </p:nvSpPr>
+        <p:spPr>
+          <a:xfrm>
+            <a:off x="1930879" y="1423059"/>
+            <a:ext cx="8330241" cy="943903"/>
+          </a:xfrm>
+        </p:spPr>
+        <p:txBody>
+          <a:bodyPr vert="horz" lIns="91440" tIns="45720" rIns="91440" bIns="45720" rtlCol="0" anchor="t">
+            <a:normAutofit/>
+          </a:bodyPr>
+          <a:lstStyle/>
+          <a:p>
+            <a:pPr marL="0" indent="0" algn="ctr">
+              <a:buNone/>
+            </a:pPr>
+            <a:r>
+              <a:rPr lang="en-GB" u="sng" dirty="0">
+                <a:solidFill>
+                  <a:schemeClr val="bg1"/>
+                </a:solidFill>
+              </a:rPr>
+              <a:t>Pre-Launch Process </a:t>
+            </a:r>
+            <a:endParaRPr lang="en-US" u="sng" dirty="0">
+              <a:solidFill>
+                <a:schemeClr val="bg1"/>
+              </a:solidFill>
+            </a:endParaRPr>
+          </a:p>
+        </p:txBody>
+      </p:sp>
+      <p:sp>
+        <p:nvSpPr>
+          <p:cNvPr id="4" name="TextBox 3">
+            <a:extLst>
+              <a:ext uri="{FF2B5EF4-FFF2-40B4-BE49-F238E27FC236}">
+                <a16:creationId xmlns:a16="http://schemas.microsoft.com/office/drawing/2014/main" id="{D782B04E-6487-5FA8-4244-2D62EB64379D}"/>
+              </a:ext>
+            </a:extLst>
+          </p:cNvPr>
+          <p:cNvSpPr txBox="1"/>
+          <p:nvPr/>
+        </p:nvSpPr>
+        <p:spPr>
+          <a:xfrm>
+            <a:off x="83390" y="2852070"/>
+            <a:ext cx="6021236" cy="2754408"/>
+          </a:xfrm>
+          <a:prstGeom prst="rect">
+            <a:avLst/>
+          </a:prstGeom>
+          <a:noFill/>
+        </p:spPr>
+        <p:txBody>
+          <a:bodyPr rot="0" spcFirstLastPara="0" vertOverflow="overflow" horzOverflow="overflow" vert="horz" wrap="square" lIns="91440" tIns="45720" rIns="91440" bIns="45720" numCol="1" spcCol="0" rtlCol="0" fromWordArt="0" anchor="t" anchorCtr="0" forceAA="0" compatLnSpc="1">
+            <a:prstTxWarp prst="textNoShape">
+              <a:avLst/>
+            </a:prstTxWarp>
+            <a:spAutoFit/>
+          </a:bodyPr>
+          <a:lstStyle/>
+          <a:p>
+            <a:pPr algn="ctr">
+              <a:lnSpc>
+                <a:spcPct val="90000"/>
+              </a:lnSpc>
+              <a:spcBef>
+                <a:spcPts val="1000"/>
+              </a:spcBef>
+            </a:pPr>
+            <a:r>
+              <a:rPr lang="en-GB" sz="3200" b="1" u="sng" dirty="0">
+                <a:solidFill>
+                  <a:schemeClr val="bg1"/>
+                </a:solidFill>
+              </a:rPr>
+              <a:t>A final round of testing, this includes: Functionality testing, compatibility testing, responsiveness testing, accessibility reviews and testing. </a:t>
+            </a:r>
+            <a:endParaRPr lang="en-US" sz="3200" b="1" u="sng" dirty="0">
+              <a:solidFill>
+                <a:schemeClr val="bg1"/>
+              </a:solidFill>
+            </a:endParaRPr>
+          </a:p>
+        </p:txBody>
+      </p:sp>
+      <p:sp>
+        <p:nvSpPr>
+          <p:cNvPr id="6" name="TextBox 5">
+            <a:extLst>
+              <a:ext uri="{FF2B5EF4-FFF2-40B4-BE49-F238E27FC236}">
+                <a16:creationId xmlns:a16="http://schemas.microsoft.com/office/drawing/2014/main" id="{1F2445EC-A1D9-AD21-CB65-5A876E48A6E4}"/>
+              </a:ext>
+            </a:extLst>
+          </p:cNvPr>
+          <p:cNvSpPr txBox="1"/>
+          <p:nvPr/>
+        </p:nvSpPr>
+        <p:spPr>
+          <a:xfrm>
+            <a:off x="6104626" y="2999116"/>
+            <a:ext cx="5661803" cy="2246769"/>
+          </a:xfrm>
+          <a:prstGeom prst="rect">
+            <a:avLst/>
+          </a:prstGeom>
+          <a:noFill/>
+        </p:spPr>
+        <p:txBody>
+          <a:bodyPr rot="0" spcFirstLastPara="0" vertOverflow="overflow" horzOverflow="overflow" vert="horz" wrap="square" lIns="91440" tIns="45720" rIns="91440" bIns="45720" numCol="1" spcCol="0" rtlCol="0" fromWordArt="0" anchor="t" anchorCtr="0" forceAA="0" compatLnSpc="1">
+            <a:prstTxWarp prst="textNoShape">
+              <a:avLst/>
+            </a:prstTxWarp>
+            <a:spAutoFit/>
+          </a:bodyPr>
+          <a:lstStyle/>
+          <a:p>
+            <a:pPr algn="ctr"/>
+            <a:r>
+              <a:rPr lang="en-GB" sz="2800">
+                <a:solidFill>
+                  <a:schemeClr val="bg1">
+                    <a:lumMod val="76000"/>
+                  </a:schemeClr>
+                </a:solidFill>
+                <a:cs typeface="Segoe UI"/>
+              </a:rPr>
+              <a:t>A complete content review should be done on the website to verify there are no spelling mistakes, grammatical errors or inappropriate content on the web page.</a:t>
+            </a:r>
+            <a:endParaRPr lang="en-GB" sz="2800" dirty="0">
+              <a:solidFill>
+                <a:schemeClr val="bg1">
+                  <a:lumMod val="76000"/>
+                </a:schemeClr>
+              </a:solidFill>
+              <a:cs typeface="Segoe UI"/>
+            </a:endParaRPr>
+          </a:p>
+        </p:txBody>
+      </p:sp>
+    </p:spTree>
+    <p:extLst>
+      <p:ext uri="{BB962C8B-B14F-4D97-AF65-F5344CB8AC3E}">
+        <p14:creationId xmlns:p14="http://schemas.microsoft.com/office/powerpoint/2010/main" val="3232360455"/>
       </p:ext>
     </p:extLst>
   </p:cSld>
@@ -4018,4 +6374,319 @@
     </a:ext>
   </a:extLst>
 </a:theme>
+</file>
+
+<file path=ppt/theme/theme2.xml><?xml version="1.0" encoding="utf-8"?>
+<a:theme xmlns:a="http://schemas.openxmlformats.org/drawingml/2006/main" name="Office Theme">
+  <a:themeElements>
+    <a:clrScheme name="Office">
+      <a:dk1>
+        <a:sysClr val="windowText" lastClr="000000"/>
+      </a:dk1>
+      <a:lt1>
+        <a:sysClr val="window" lastClr="FFFFFF"/>
+      </a:lt1>
+      <a:dk2>
+        <a:srgbClr val="0E2841"/>
+      </a:dk2>
+      <a:lt2>
+        <a:srgbClr val="E8E8E8"/>
+      </a:lt2>
+      <a:accent1>
+        <a:srgbClr val="156082"/>
+      </a:accent1>
+      <a:accent2>
+        <a:srgbClr val="E97132"/>
+      </a:accent2>
+      <a:accent3>
+        <a:srgbClr val="196B24"/>
+      </a:accent3>
+      <a:accent4>
+        <a:srgbClr val="0F9ED5"/>
+      </a:accent4>
+      <a:accent5>
+        <a:srgbClr val="A02B93"/>
+      </a:accent5>
+      <a:accent6>
+        <a:srgbClr val="4EA72E"/>
+      </a:accent6>
+      <a:hlink>
+        <a:srgbClr val="467886"/>
+      </a:hlink>
+      <a:folHlink>
+        <a:srgbClr val="96607D"/>
+      </a:folHlink>
+    </a:clrScheme>
+    <a:fontScheme name="Office">
+      <a:majorFont>
+        <a:latin typeface="Aptos Display" panose="02110004020202020204"/>
+        <a:ea typeface=""/>
+        <a:cs typeface=""/>
+        <a:font script="Jpan" typeface="游ゴシック Light"/>
+        <a:font script="Hang" typeface="맑은 고딕"/>
+        <a:font script="Hans" typeface="等线 Light"/>
+        <a:font script="Hant" typeface="新細明體"/>
+        <a:font script="Arab" typeface="Times New Roman"/>
+        <a:font script="Hebr" typeface="Times New Roman"/>
+        <a:font script="Thai" typeface="Angsana New"/>
+        <a:font script="Ethi" typeface="Nyala"/>
+        <a:font script="Beng" typeface="Vrinda"/>
+        <a:font script="Gujr" typeface="Shruti"/>
+        <a:font script="Khmr" typeface="MoolBoran"/>
+        <a:font script="Knda" typeface="Tunga"/>
+        <a:font script="Guru" typeface="Raavi"/>
+        <a:font script="Cans" typeface="Euphemia"/>
+        <a:font script="Cher" typeface="Plantagenet Cherokee"/>
+        <a:font script="Yiii" typeface="Microsoft Yi Baiti"/>
+        <a:font script="Tibt" typeface="Microsoft Himalaya"/>
+        <a:font script="Thaa" typeface="MV Boli"/>
+        <a:font script="Deva" typeface="Mangal"/>
+        <a:font script="Telu" typeface="Gautami"/>
+        <a:font script="Taml" typeface="Latha"/>
+        <a:font script="Syrc" typeface="Estrangelo Edessa"/>
+        <a:font script="Orya" typeface="Kalinga"/>
+        <a:font script="Mlym" typeface="Kartika"/>
+        <a:font script="Laoo" typeface="DokChampa"/>
+        <a:font script="Sinh" typeface="Iskoola Pota"/>
+        <a:font script="Mong" typeface="Mongolian Baiti"/>
+        <a:font script="Viet" typeface="Times New Roman"/>
+        <a:font script="Uigh" typeface="Microsoft Uighur"/>
+        <a:font script="Geor" typeface="Sylfaen"/>
+        <a:font script="Armn" typeface="Arial"/>
+        <a:font script="Bugi" typeface="Leelawadee UI"/>
+        <a:font script="Bopo" typeface="Microsoft JhengHei"/>
+        <a:font script="Java" typeface="Javanese Text"/>
+        <a:font script="Lisu" typeface="Segoe UI"/>
+        <a:font script="Mymr" typeface="Myanmar Text"/>
+        <a:font script="Nkoo" typeface="Ebrima"/>
+        <a:font script="Olck" typeface="Nirmala UI"/>
+        <a:font script="Osma" typeface="Ebrima"/>
+        <a:font script="Phag" typeface="Phagspa"/>
+        <a:font script="Syrn" typeface="Estrangelo Edessa"/>
+        <a:font script="Syrj" typeface="Estrangelo Edessa"/>
+        <a:font script="Syre" typeface="Estrangelo Edessa"/>
+        <a:font script="Sora" typeface="Nirmala UI"/>
+        <a:font script="Tale" typeface="Microsoft Tai Le"/>
+        <a:font script="Talu" typeface="Microsoft New Tai Lue"/>
+        <a:font script="Tfng" typeface="Ebrima"/>
+      </a:majorFont>
+      <a:minorFont>
+        <a:latin typeface="Aptos" panose="02110004020202020204"/>
+        <a:ea typeface=""/>
+        <a:cs typeface=""/>
+        <a:font script="Jpan" typeface="游ゴシック"/>
+        <a:font script="Hang" typeface="맑은 고딕"/>
+        <a:font script="Hans" typeface="等线"/>
+        <a:font script="Hant" typeface="新細明體"/>
+        <a:font script="Arab" typeface="Arial"/>
+        <a:font script="Hebr" typeface="Arial"/>
+        <a:font script="Thai" typeface="Cordia New"/>
+        <a:font script="Ethi" typeface="Nyala"/>
+        <a:font script="Beng" typeface="Vrinda"/>
+        <a:font script="Gujr" typeface="Shruti"/>
+        <a:font script="Khmr" typeface="DaunPenh"/>
+        <a:font script="Knda" typeface="Tunga"/>
+        <a:font script="Guru" typeface="Raavi"/>
+        <a:font script="Cans" typeface="Euphemia"/>
+        <a:font script="Cher" typeface="Plantagenet Cherokee"/>
+        <a:font script="Yiii" typeface="Microsoft Yi Baiti"/>
+        <a:font script="Tibt" typeface="Microsoft Himalaya"/>
+        <a:font script="Thaa" typeface="MV Boli"/>
+        <a:font script="Deva" typeface="Mangal"/>
+        <a:font script="Telu" typeface="Gautami"/>
+        <a:font script="Taml" typeface="Latha"/>
+        <a:font script="Syrc" typeface="Estrangelo Edessa"/>
+        <a:font script="Orya" typeface="Kalinga"/>
+        <a:font script="Mlym" typeface="Kartika"/>
+        <a:font script="Laoo" typeface="DokChampa"/>
+        <a:font script="Sinh" typeface="Iskoola Pota"/>
+        <a:font script="Mong" typeface="Mongolian Baiti"/>
+        <a:font script="Viet" typeface="Arial"/>
+        <a:font script="Uigh" typeface="Microsoft Uighur"/>
+        <a:font script="Geor" typeface="Sylfaen"/>
+        <a:font script="Armn" typeface="Arial"/>
+        <a:font script="Bugi" typeface="Leelawadee UI"/>
+        <a:font script="Bopo" typeface="Microsoft JhengHei"/>
+        <a:font script="Java" typeface="Javanese Text"/>
+        <a:font script="Lisu" typeface="Segoe UI"/>
+        <a:font script="Mymr" typeface="Myanmar Text"/>
+        <a:font script="Nkoo" typeface="Ebrima"/>
+        <a:font script="Olck" typeface="Nirmala UI"/>
+        <a:font script="Osma" typeface="Ebrima"/>
+        <a:font script="Phag" typeface="Phagspa"/>
+        <a:font script="Syrn" typeface="Estrangelo Edessa"/>
+        <a:font script="Syrj" typeface="Estrangelo Edessa"/>
+        <a:font script="Syre" typeface="Estrangelo Edessa"/>
+        <a:font script="Sora" typeface="Nirmala UI"/>
+        <a:font script="Tale" typeface="Microsoft Tai Le"/>
+        <a:font script="Talu" typeface="Microsoft New Tai Lue"/>
+        <a:font script="Tfng" typeface="Ebrima"/>
+      </a:minorFont>
+    </a:fontScheme>
+    <a:fmtScheme name="Office">
+      <a:fillStyleLst>
+        <a:solidFill>
+          <a:schemeClr val="phClr"/>
+        </a:solidFill>
+        <a:gradFill rotWithShape="1">
+          <a:gsLst>
+            <a:gs pos="0">
+              <a:schemeClr val="phClr">
+                <a:lumMod val="110000"/>
+                <a:satMod val="105000"/>
+                <a:tint val="67000"/>
+              </a:schemeClr>
+            </a:gs>
+            <a:gs pos="50000">
+              <a:schemeClr val="phClr">
+                <a:lumMod val="105000"/>
+                <a:satMod val="103000"/>
+                <a:tint val="73000"/>
+              </a:schemeClr>
+            </a:gs>
+            <a:gs pos="100000">
+              <a:schemeClr val="phClr">
+                <a:lumMod val="105000"/>
+                <a:satMod val="109000"/>
+                <a:tint val="81000"/>
+              </a:schemeClr>
+            </a:gs>
+          </a:gsLst>
+          <a:lin ang="5400000" scaled="0"/>
+        </a:gradFill>
+        <a:gradFill rotWithShape="1">
+          <a:gsLst>
+            <a:gs pos="0">
+              <a:schemeClr val="phClr">
+                <a:satMod val="103000"/>
+                <a:lumMod val="102000"/>
+                <a:tint val="94000"/>
+              </a:schemeClr>
+            </a:gs>
+            <a:gs pos="50000">
+              <a:schemeClr val="phClr">
+                <a:satMod val="110000"/>
+                <a:lumMod val="100000"/>
+                <a:shade val="100000"/>
+              </a:schemeClr>
+            </a:gs>
+            <a:gs pos="100000">
+              <a:schemeClr val="phClr">
+                <a:lumMod val="99000"/>
+                <a:satMod val="120000"/>
+                <a:shade val="78000"/>
+              </a:schemeClr>
+            </a:gs>
+          </a:gsLst>
+          <a:lin ang="5400000" scaled="0"/>
+        </a:gradFill>
+      </a:fillStyleLst>
+      <a:lnStyleLst>
+        <a:ln w="12700" cap="flat" cmpd="sng" algn="ctr">
+          <a:solidFill>
+            <a:schemeClr val="phClr"/>
+          </a:solidFill>
+          <a:prstDash val="solid"/>
+          <a:miter lim="800000"/>
+        </a:ln>
+        <a:ln w="19050" cap="flat" cmpd="sng" algn="ctr">
+          <a:solidFill>
+            <a:schemeClr val="phClr"/>
+          </a:solidFill>
+          <a:prstDash val="solid"/>
+          <a:miter lim="800000"/>
+        </a:ln>
+        <a:ln w="25400" cap="flat" cmpd="sng" algn="ctr">
+          <a:solidFill>
+            <a:schemeClr val="phClr"/>
+          </a:solidFill>
+          <a:prstDash val="solid"/>
+          <a:miter lim="800000"/>
+        </a:ln>
+      </a:lnStyleLst>
+      <a:effectStyleLst>
+        <a:effectStyle>
+          <a:effectLst/>
+        </a:effectStyle>
+        <a:effectStyle>
+          <a:effectLst/>
+        </a:effectStyle>
+        <a:effectStyle>
+          <a:effectLst>
+            <a:outerShdw blurRad="57150" dist="19050" dir="5400000" algn="ctr" rotWithShape="0">
+              <a:srgbClr val="000000">
+                <a:alpha val="63000"/>
+              </a:srgbClr>
+            </a:outerShdw>
+          </a:effectLst>
+        </a:effectStyle>
+      </a:effectStyleLst>
+      <a:bgFillStyleLst>
+        <a:solidFill>
+          <a:schemeClr val="phClr"/>
+        </a:solidFill>
+        <a:solidFill>
+          <a:schemeClr val="phClr">
+            <a:tint val="95000"/>
+            <a:satMod val="170000"/>
+          </a:schemeClr>
+        </a:solidFill>
+        <a:gradFill rotWithShape="1">
+          <a:gsLst>
+            <a:gs pos="0">
+              <a:schemeClr val="phClr">
+                <a:tint val="93000"/>
+                <a:satMod val="150000"/>
+                <a:shade val="98000"/>
+                <a:lumMod val="102000"/>
+              </a:schemeClr>
+            </a:gs>
+            <a:gs pos="50000">
+              <a:schemeClr val="phClr">
+                <a:tint val="98000"/>
+                <a:satMod val="130000"/>
+                <a:shade val="90000"/>
+                <a:lumMod val="103000"/>
+              </a:schemeClr>
+            </a:gs>
+            <a:gs pos="100000">
+              <a:schemeClr val="phClr">
+                <a:shade val="63000"/>
+                <a:satMod val="120000"/>
+              </a:schemeClr>
+            </a:gs>
+          </a:gsLst>
+          <a:lin ang="5400000" scaled="0"/>
+        </a:gradFill>
+      </a:bgFillStyleLst>
+    </a:fmtScheme>
+  </a:themeElements>
+  <a:objectDefaults>
+    <a:lnDef>
+      <a:spPr/>
+      <a:bodyPr/>
+      <a:lstStyle/>
+      <a:style>
+        <a:lnRef idx="2">
+          <a:schemeClr val="accent1"/>
+        </a:lnRef>
+        <a:fillRef idx="0">
+          <a:schemeClr val="accent1"/>
+        </a:fillRef>
+        <a:effectRef idx="1">
+          <a:schemeClr val="accent1"/>
+        </a:effectRef>
+        <a:fontRef idx="minor">
+          <a:schemeClr val="tx1"/>
+        </a:fontRef>
+      </a:style>
+    </a:lnDef>
+  </a:objectDefaults>
+  <a:extraClrSchemeLst/>
+  <a:extLst>
+    <a:ext uri="{05A4C25C-085E-4340-85A3-A5531E510DB2}">
+      <thm15:themeFamily xmlns:thm15="http://schemas.microsoft.com/office/thememl/2012/main" name="Office Theme" id="{2E142A2C-CD16-42D6-873A-C26D2A0506FA}" vid="{1BDDFF52-6CD6-40A5-AB3C-68EB2F1E4D0A}"/>
+    </a:ext>
+  </a:extLst>
+</a:theme>
 </file>
</xml_diff>